<commit_message>
add architectural notes, and add class to manage incoming data, from an event. (the OS or protocol specific evetn will be managed by the user of this class.
</commit_message>
<xml_diff>
--- a/Documentation/ProjectArchitecture.pptx
+++ b/Documentation/ProjectArchitecture.pptx
@@ -6,8 +6,12 @@
   </p:sldMasterIdLst>
   <p:sldIdLst>
     <p:sldId id="256" r:id="rId2"/>
-    <p:sldId id="257" r:id="rId3"/>
-    <p:sldId id="258" r:id="rId4"/>
+    <p:sldId id="259" r:id="rId3"/>
+    <p:sldId id="262" r:id="rId4"/>
+    <p:sldId id="260" r:id="rId5"/>
+    <p:sldId id="261" r:id="rId6"/>
+    <p:sldId id="263" r:id="rId7"/>
+    <p:sldId id="264" r:id="rId8"/>
   </p:sldIdLst>
   <p:sldSz cx="12192000" cy="6858000"/>
   <p:notesSz cx="6858000" cy="9144000"/>
@@ -261,7 +265,7 @@
           <a:p>
             <a:fld id="{82B1C2C3-D437-4CB5-914C-06113AC135BA}" type="datetimeFigureOut">
               <a:rPr lang="en-US" smtClean="0"/>
-              <a:t>1/21/2026</a:t>
+              <a:t>3/2/2026</a:t>
             </a:fld>
             <a:endParaRPr lang="en-US"/>
           </a:p>
@@ -459,7 +463,7 @@
           <a:p>
             <a:fld id="{82B1C2C3-D437-4CB5-914C-06113AC135BA}" type="datetimeFigureOut">
               <a:rPr lang="en-US" smtClean="0"/>
-              <a:t>1/21/2026</a:t>
+              <a:t>3/2/2026</a:t>
             </a:fld>
             <a:endParaRPr lang="en-US"/>
           </a:p>
@@ -667,7 +671,7 @@
           <a:p>
             <a:fld id="{82B1C2C3-D437-4CB5-914C-06113AC135BA}" type="datetimeFigureOut">
               <a:rPr lang="en-US" smtClean="0"/>
-              <a:t>1/21/2026</a:t>
+              <a:t>3/2/2026</a:t>
             </a:fld>
             <a:endParaRPr lang="en-US"/>
           </a:p>
@@ -865,7 +869,7 @@
           <a:p>
             <a:fld id="{82B1C2C3-D437-4CB5-914C-06113AC135BA}" type="datetimeFigureOut">
               <a:rPr lang="en-US" smtClean="0"/>
-              <a:t>1/21/2026</a:t>
+              <a:t>3/2/2026</a:t>
             </a:fld>
             <a:endParaRPr lang="en-US"/>
           </a:p>
@@ -1140,7 +1144,7 @@
           <a:p>
             <a:fld id="{82B1C2C3-D437-4CB5-914C-06113AC135BA}" type="datetimeFigureOut">
               <a:rPr lang="en-US" smtClean="0"/>
-              <a:t>1/21/2026</a:t>
+              <a:t>3/2/2026</a:t>
             </a:fld>
             <a:endParaRPr lang="en-US"/>
           </a:p>
@@ -1405,7 +1409,7 @@
           <a:p>
             <a:fld id="{82B1C2C3-D437-4CB5-914C-06113AC135BA}" type="datetimeFigureOut">
               <a:rPr lang="en-US" smtClean="0"/>
-              <a:t>1/21/2026</a:t>
+              <a:t>3/2/2026</a:t>
             </a:fld>
             <a:endParaRPr lang="en-US"/>
           </a:p>
@@ -1817,7 +1821,7 @@
           <a:p>
             <a:fld id="{82B1C2C3-D437-4CB5-914C-06113AC135BA}" type="datetimeFigureOut">
               <a:rPr lang="en-US" smtClean="0"/>
-              <a:t>1/21/2026</a:t>
+              <a:t>3/2/2026</a:t>
             </a:fld>
             <a:endParaRPr lang="en-US"/>
           </a:p>
@@ -1958,7 +1962,7 @@
           <a:p>
             <a:fld id="{82B1C2C3-D437-4CB5-914C-06113AC135BA}" type="datetimeFigureOut">
               <a:rPr lang="en-US" smtClean="0"/>
-              <a:t>1/21/2026</a:t>
+              <a:t>3/2/2026</a:t>
             </a:fld>
             <a:endParaRPr lang="en-US"/>
           </a:p>
@@ -2071,7 +2075,7 @@
           <a:p>
             <a:fld id="{82B1C2C3-D437-4CB5-914C-06113AC135BA}" type="datetimeFigureOut">
               <a:rPr lang="en-US" smtClean="0"/>
-              <a:t>1/21/2026</a:t>
+              <a:t>3/2/2026</a:t>
             </a:fld>
             <a:endParaRPr lang="en-US"/>
           </a:p>
@@ -2382,7 +2386,7 @@
           <a:p>
             <a:fld id="{82B1C2C3-D437-4CB5-914C-06113AC135BA}" type="datetimeFigureOut">
               <a:rPr lang="en-US" smtClean="0"/>
-              <a:t>1/21/2026</a:t>
+              <a:t>3/2/2026</a:t>
             </a:fld>
             <a:endParaRPr lang="en-US"/>
           </a:p>
@@ -2670,7 +2674,7 @@
           <a:p>
             <a:fld id="{82B1C2C3-D437-4CB5-914C-06113AC135BA}" type="datetimeFigureOut">
               <a:rPr lang="en-US" smtClean="0"/>
-              <a:t>1/21/2026</a:t>
+              <a:t>3/2/2026</a:t>
             </a:fld>
             <a:endParaRPr lang="en-US"/>
           </a:p>
@@ -2911,7 +2915,7 @@
           <a:p>
             <a:fld id="{82B1C2C3-D437-4CB5-914C-06113AC135BA}" type="datetimeFigureOut">
               <a:rPr lang="en-US" smtClean="0"/>
-              <a:t>1/21/2026</a:t>
+              <a:t>3/2/2026</a:t>
             </a:fld>
             <a:endParaRPr lang="en-US"/>
           </a:p>
@@ -3344,49 +3348,60 @@
             <p:ph type="ctrTitle"/>
           </p:nvPr>
         </p:nvSpPr>
+        <p:spPr>
+          <a:xfrm>
+            <a:off x="593235" y="406400"/>
+            <a:ext cx="10913476" cy="2387600"/>
+          </a:xfrm>
+        </p:spPr>
+        <p:txBody>
+          <a:bodyPr/>
+          <a:lstStyle/>
+          <a:p>
+            <a:r>
+              <a:rPr lang="en-US"/>
+              <a:t>Chat Healthy	</a:t>
+            </a:r>
+            <a:br>
+              <a:rPr lang="en-US"/>
+            </a:br>
+            <a:r>
+              <a:rPr lang="en-US" sz="3200" i="1"/>
+              <a:t>A Consumer web site supporting a chat interface to finding care</a:t>
+            </a:r>
+            <a:br>
+              <a:rPr lang="en-US"/>
+            </a:br>
+            <a:endParaRPr lang="en-US" sz="2800" dirty="0"/>
+          </a:p>
+        </p:txBody>
+      </p:sp>
+      <p:sp>
+        <p:nvSpPr>
+          <p:cNvPr id="3" name="Subtitle 2">
+            <a:extLst>
+              <a:ext uri="{FF2B5EF4-FFF2-40B4-BE49-F238E27FC236}">
+                <a16:creationId xmlns:a16="http://schemas.microsoft.com/office/drawing/2014/main" id="{C04DD1E0-AAE0-588B-2D95-6618B63A2AD5}"/>
+              </a:ext>
+            </a:extLst>
+          </p:cNvPr>
+          <p:cNvSpPr>
+            <a:spLocks noGrp="1"/>
+          </p:cNvSpPr>
+          <p:nvPr>
+            <p:ph type="subTitle" idx="1"/>
+          </p:nvPr>
+        </p:nvSpPr>
         <p:spPr/>
         <p:txBody>
           <a:bodyPr/>
           <a:lstStyle/>
           <a:p>
             <a:r>
-              <a:rPr lang="en-US" dirty="0"/>
-              <a:t>Chat Healthy	</a:t>
-            </a:r>
-          </a:p>
-        </p:txBody>
-      </p:sp>
-      <p:sp>
-        <p:nvSpPr>
-          <p:cNvPr id="3" name="Subtitle 2">
-            <a:extLst>
-              <a:ext uri="{FF2B5EF4-FFF2-40B4-BE49-F238E27FC236}">
-                <a16:creationId xmlns:a16="http://schemas.microsoft.com/office/drawing/2014/main" id="{C04DD1E0-AAE0-588B-2D95-6618B63A2AD5}"/>
-              </a:ext>
-            </a:extLst>
-          </p:cNvPr>
-          <p:cNvSpPr>
-            <a:spLocks noGrp="1"/>
-          </p:cNvSpPr>
-          <p:nvPr>
-            <p:ph type="subTitle" idx="1"/>
-          </p:nvPr>
-        </p:nvSpPr>
-        <p:spPr/>
-        <p:txBody>
-          <a:bodyPr/>
-          <a:lstStyle/>
-          <a:p>
-            <a:r>
-              <a:rPr lang="en-US" dirty="0"/>
-              <a:t>Phase 1 architecture:</a:t>
-            </a:r>
-          </a:p>
-          <a:p>
-            <a:r>
-              <a:rPr lang="en-US" dirty="0"/>
-              <a:t>Project for LLM engineering course. </a:t>
-            </a:r>
+              <a:rPr lang="en-US"/>
+              <a:t>https://www.chathealthy.ai</a:t>
+            </a:r>
+            <a:endParaRPr lang="en-US" dirty="0"/>
           </a:p>
         </p:txBody>
       </p:sp>
@@ -3425,7 +3440,7 @@
           <p:cNvPr id="2" name="Title 1">
             <a:extLst>
               <a:ext uri="{FF2B5EF4-FFF2-40B4-BE49-F238E27FC236}">
-                <a16:creationId xmlns:a16="http://schemas.microsoft.com/office/drawing/2014/main" id="{A909C5E5-C67A-BC61-A0CC-952D05681612}"/>
+                <a16:creationId xmlns:a16="http://schemas.microsoft.com/office/drawing/2014/main" id="{E5887721-0EA8-D9F6-8F33-FCE1615E926D}"/>
               </a:ext>
             </a:extLst>
           </p:cNvPr>
@@ -3434,230 +3449,97 @@
           </p:cNvSpPr>
           <p:nvPr>
             <p:ph type="title"/>
-          </p:nvPr>
-        </p:nvSpPr>
-        <p:spPr/>
-        <p:txBody>
-          <a:bodyPr/>
-          <a:lstStyle/>
-          <a:p>
-            <a:r>
-              <a:rPr lang="en-US" dirty="0"/>
-              <a:t>Overview</a:t>
-            </a:r>
-          </a:p>
-        </p:txBody>
-      </p:sp>
-      <p:sp>
-        <p:nvSpPr>
-          <p:cNvPr id="3" name="Content Placeholder 2">
-            <a:extLst>
-              <a:ext uri="{FF2B5EF4-FFF2-40B4-BE49-F238E27FC236}">
-                <a16:creationId xmlns:a16="http://schemas.microsoft.com/office/drawing/2014/main" id="{5DA7233E-1F99-2285-EC5C-6DFBDC4192AB}"/>
-              </a:ext>
-            </a:extLst>
-          </p:cNvPr>
-          <p:cNvSpPr>
-            <a:spLocks noGrp="1"/>
-          </p:cNvSpPr>
-          <p:nvPr>
-            <p:ph idx="1"/>
           </p:nvPr>
         </p:nvSpPr>
         <p:spPr>
           <a:xfrm>
-            <a:off x="725466" y="1253331"/>
+            <a:off x="149087" y="0"/>
+            <a:ext cx="10515600" cy="1325563"/>
+          </a:xfrm>
+        </p:spPr>
+        <p:txBody>
+          <a:bodyPr/>
+          <a:lstStyle/>
+          <a:p>
+            <a:r>
+              <a:rPr lang="en-US" dirty="0"/>
+              <a:t>Project goals</a:t>
+            </a:r>
+          </a:p>
+        </p:txBody>
+      </p:sp>
+      <p:sp>
+        <p:nvSpPr>
+          <p:cNvPr id="3" name="Content Placeholder 2">
+            <a:extLst>
+              <a:ext uri="{FF2B5EF4-FFF2-40B4-BE49-F238E27FC236}">
+                <a16:creationId xmlns:a16="http://schemas.microsoft.com/office/drawing/2014/main" id="{ED01B8D9-DA65-FC4E-DF50-72FE67B3F2B5}"/>
+              </a:ext>
+            </a:extLst>
+          </p:cNvPr>
+          <p:cNvSpPr>
+            <a:spLocks noGrp="1"/>
+          </p:cNvSpPr>
+          <p:nvPr>
+            <p:ph idx="1"/>
+          </p:nvPr>
+        </p:nvSpPr>
+        <p:spPr>
+          <a:xfrm>
+            <a:off x="838200" y="1500369"/>
             <a:ext cx="10515600" cy="4351338"/>
           </a:xfrm>
         </p:spPr>
         <p:txBody>
-          <a:bodyPr>
-            <a:normAutofit fontScale="70000" lnSpcReduction="20000"/>
-          </a:bodyPr>
+          <a:bodyPr/>
           <a:lstStyle/>
           <a:p>
             <a:r>
               <a:rPr lang="en-US" dirty="0"/>
-              <a:t>This project evaluates and tries to find the best model with the best augmentation via QLoRA and or Rag to predict how many specialists work in any one county. </a:t>
+              <a:t>Create website that:</a:t>
             </a:r>
           </a:p>
           <a:p>
             <a:pPr lvl="1"/>
             <a:r>
               <a:rPr lang="en-US" dirty="0"/>
-              <a:t>A data pipeline will be built</a:t>
-            </a:r>
-          </a:p>
-          <a:p>
-            <a:pPr lvl="2"/>
+              <a:t> Allows via chat interface a user to find care.</a:t>
+            </a:r>
+          </a:p>
+          <a:p>
+            <a:pPr lvl="1"/>
             <a:r>
               <a:rPr lang="en-US" dirty="0"/>
-              <a:t>Provider data</a:t>
-            </a:r>
-          </a:p>
-          <a:p>
-            <a:pPr lvl="2"/>
+              <a:t>Keep data fresh and accurate (phase 1 operational)</a:t>
+            </a:r>
+          </a:p>
+          <a:p>
+            <a:pPr lvl="1"/>
             <a:r>
               <a:rPr lang="en-US" dirty="0"/>
-              <a:t>County Zip Mapping</a:t>
-            </a:r>
-          </a:p>
-          <a:p>
-            <a:pPr lvl="2"/>
+              <a:t>Allow users to ask general questions about the American health care system.</a:t>
+            </a:r>
+          </a:p>
+          <a:p>
+            <a:pPr lvl="1"/>
             <a:r>
               <a:rPr lang="en-US" dirty="0"/>
-              <a:t>County GDP added to County Specialist Zip Map</a:t>
-            </a:r>
-          </a:p>
-          <a:p>
-            <a:pPr lvl="2"/>
+              <a:t>Do not under any circumstances give medical advise beyond what types of care to seek	 based on user input.</a:t>
+            </a:r>
+          </a:p>
+          <a:p>
+            <a:pPr lvl="1"/>
+            <a:r>
+              <a:rPr lang="en-US" dirty="0"/>
+              <a:t>While ensuring user privacy, keep a log of user </a:t>
+            </a:r>
             <a:r>
               <a:rPr lang="en-US" dirty="0" err="1"/>
-              <a:t>Coutny</a:t>
+              <a:t>activiteis</a:t>
             </a:r>
             <a:r>
               <a:rPr lang="en-US" dirty="0"/>
-              <a:t> Population bands will be added to County specialist zip map.</a:t>
-            </a:r>
-          </a:p>
-          <a:p>
-            <a:pPr lvl="2"/>
-            <a:r>
-              <a:rPr lang="en-US" dirty="0"/>
-              <a:t>Number of docs per specialty will be added to County Specialist Zip Map</a:t>
-            </a:r>
-          </a:p>
-          <a:p>
-            <a:pPr lvl="2"/>
-            <a:r>
-              <a:rPr lang="en-US" dirty="0"/>
-              <a:t>Specialist descriptions will be an entity for training for </a:t>
-            </a:r>
-            <a:r>
-              <a:rPr lang="en-US" dirty="0" err="1"/>
-              <a:t>Qlaura</a:t>
-            </a:r>
-            <a:r>
-              <a:rPr lang="en-US" dirty="0"/>
-              <a:t>. </a:t>
-            </a:r>
-          </a:p>
-          <a:p>
-            <a:pPr lvl="1"/>
-            <a:r>
-              <a:rPr lang="en-US" dirty="0"/>
-              <a:t>The experiments will add to the data set’s features and continue to search for the best answer to natural language interrogation to figure out what humans will ask of the model and steering them in the right direction. </a:t>
-            </a:r>
-          </a:p>
-          <a:p>
-            <a:pPr lvl="1"/>
-            <a:r>
-              <a:rPr lang="en-US" dirty="0"/>
-              <a:t>All frontier models will be asked 1000 test questions with definitive quantitative answers. </a:t>
-            </a:r>
-          </a:p>
-          <a:p>
-            <a:pPr lvl="2"/>
-            <a:r>
-              <a:rPr lang="en-US" dirty="0"/>
-              <a:t>Their answers will be compared. </a:t>
-            </a:r>
-          </a:p>
-          <a:p>
-            <a:pPr lvl="1"/>
-            <a:r>
-              <a:rPr lang="en-US" dirty="0" err="1"/>
-              <a:t>Olama</a:t>
-            </a:r>
-            <a:r>
-              <a:rPr lang="en-US" dirty="0"/>
-              <a:t> will be enhanced with QLoRA</a:t>
-            </a:r>
-          </a:p>
-          <a:p>
-            <a:pPr lvl="2"/>
-            <a:r>
-              <a:rPr lang="en-US" dirty="0"/>
-              <a:t>Three rounds of training will be done. </a:t>
-            </a:r>
-          </a:p>
-          <a:p>
-            <a:pPr lvl="1"/>
-            <a:r>
-              <a:rPr lang="en-US" dirty="0"/>
-              <a:t>New dimension will be added to the </a:t>
-            </a:r>
-          </a:p>
-          <a:p>
-            <a:pPr lvl="1"/>
-            <a:r>
-              <a:rPr lang="en-US" dirty="0"/>
-              <a:t>All frontier models will be retested with the new data</a:t>
-            </a:r>
-          </a:p>
-          <a:p>
-            <a:pPr lvl="1"/>
-            <a:r>
-              <a:rPr lang="en-US" dirty="0"/>
-              <a:t>All models will be augmented via RAG and the </a:t>
-            </a:r>
-            <a:r>
-              <a:rPr lang="en-US" dirty="0" err="1"/>
-              <a:t>vecorized</a:t>
-            </a:r>
-            <a:r>
-              <a:rPr lang="en-US" dirty="0"/>
-              <a:t> data near the answer to the question. </a:t>
-            </a:r>
-          </a:p>
-          <a:p>
-            <a:pPr lvl="1"/>
-            <a:endParaRPr lang="en-US" dirty="0"/>
-          </a:p>
-          <a:p>
-            <a:pPr lvl="1"/>
-            <a:endParaRPr lang="en-US" dirty="0"/>
-          </a:p>
-          <a:p>
-            <a:pPr lvl="1"/>
-            <a:endParaRPr lang="en-US" dirty="0"/>
-          </a:p>
-          <a:p>
-            <a:endParaRPr lang="en-US" dirty="0"/>
-          </a:p>
-        </p:txBody>
-      </p:sp>
-      <p:sp>
-        <p:nvSpPr>
-          <p:cNvPr id="4" name="TextBox 3">
-            <a:extLst>
-              <a:ext uri="{FF2B5EF4-FFF2-40B4-BE49-F238E27FC236}">
-                <a16:creationId xmlns:a16="http://schemas.microsoft.com/office/drawing/2014/main" id="{CFA0ADAF-CAF4-3508-2482-C1AD9EEA37A0}"/>
-              </a:ext>
-            </a:extLst>
-          </p:cNvPr>
-          <p:cNvSpPr txBox="1"/>
-          <p:nvPr/>
-        </p:nvSpPr>
-        <p:spPr>
-          <a:xfrm>
-            <a:off x="200416" y="6396335"/>
-            <a:ext cx="7992649" cy="461665"/>
-          </a:xfrm>
-          <a:prstGeom prst="rect">
-            <a:avLst/>
-          </a:prstGeom>
-          <a:noFill/>
-        </p:spPr>
-        <p:txBody>
-          <a:bodyPr wrap="square" rtlCol="0">
-            <a:spAutoFit/>
-          </a:bodyPr>
-          <a:lstStyle/>
-          <a:p>
-            <a:r>
-              <a:rPr lang="en-US" sz="1200" dirty="0"/>
-              <a:t>1: I will take the Agentic course next and incorporate agentic aspects to the project and UX within the context of that course</a:t>
+              <a:t> based on cookies and or registration. (Ensure that the HIPAA laws around ‘research data are preserved and declare in privacy statement that all user data is anonymized as per HIPAA standards. </a:t>
             </a:r>
           </a:p>
         </p:txBody>
@@ -3665,7 +3547,7 @@
     </p:spTree>
     <p:extLst>
       <p:ext uri="{BB962C8B-B14F-4D97-AF65-F5344CB8AC3E}">
-        <p14:creationId xmlns:p14="http://schemas.microsoft.com/office/powerpoint/2010/main" val="869620980"/>
+        <p14:creationId xmlns:p14="http://schemas.microsoft.com/office/powerpoint/2010/main" val="2044576727"/>
       </p:ext>
     </p:extLst>
   </p:cSld>
@@ -3697,7 +3579,7 @@
           <p:cNvPr id="2" name="Title 1">
             <a:extLst>
               <a:ext uri="{FF2B5EF4-FFF2-40B4-BE49-F238E27FC236}">
-                <a16:creationId xmlns:a16="http://schemas.microsoft.com/office/drawing/2014/main" id="{F25B9C94-8FF7-E02B-FE6A-29B8BD9B598F}"/>
+                <a16:creationId xmlns:a16="http://schemas.microsoft.com/office/drawing/2014/main" id="{E7EF3A8B-45CB-F213-3E39-9E312BA74D76}"/>
               </a:ext>
             </a:extLst>
           </p:cNvPr>
@@ -3708,455 +3590,84 @@
             <p:ph type="title"/>
           </p:nvPr>
         </p:nvSpPr>
-        <p:spPr/>
-        <p:txBody>
-          <a:bodyPr/>
-          <a:lstStyle/>
-          <a:p>
-            <a:r>
-              <a:rPr lang="en-US" dirty="0"/>
-              <a:t>Core model for interrogation</a:t>
-            </a:r>
-          </a:p>
-        </p:txBody>
-      </p:sp>
-      <p:grpSp>
-        <p:nvGrpSpPr>
-          <p:cNvPr id="8" name="Group 7">
-            <a:extLst>
-              <a:ext uri="{FF2B5EF4-FFF2-40B4-BE49-F238E27FC236}">
-                <a16:creationId xmlns:a16="http://schemas.microsoft.com/office/drawing/2014/main" id="{2D00531B-936D-4FB0-A06B-1E1F90B6159D}"/>
-              </a:ext>
-            </a:extLst>
-          </p:cNvPr>
-          <p:cNvGrpSpPr/>
-          <p:nvPr/>
-        </p:nvGrpSpPr>
-        <p:grpSpPr>
-          <a:xfrm>
-            <a:off x="1014608" y="1690688"/>
-            <a:ext cx="1678488" cy="1628709"/>
-            <a:chOff x="1014608" y="1690688"/>
-            <a:chExt cx="1678488" cy="1628709"/>
-          </a:xfrm>
-        </p:grpSpPr>
-        <p:sp>
-          <p:nvSpPr>
-            <p:cNvPr id="6" name="Rectangle 5">
-              <a:extLst>
-                <a:ext uri="{FF2B5EF4-FFF2-40B4-BE49-F238E27FC236}">
-                  <a16:creationId xmlns:a16="http://schemas.microsoft.com/office/drawing/2014/main" id="{D5ACC21A-E6EF-7DA0-7FF3-37BDD3B89E39}"/>
-                </a:ext>
-              </a:extLst>
-            </p:cNvPr>
-            <p:cNvSpPr/>
-            <p:nvPr/>
-          </p:nvSpPr>
-          <p:spPr>
-            <a:xfrm>
-              <a:off x="1014608" y="1690688"/>
-              <a:ext cx="1678488" cy="413685"/>
-            </a:xfrm>
-            <a:prstGeom prst="rect">
-              <a:avLst/>
-            </a:prstGeom>
-            <a:solidFill>
-              <a:schemeClr val="bg2">
-                <a:lumMod val="90000"/>
-              </a:schemeClr>
-            </a:solidFill>
-          </p:spPr>
-          <p:style>
-            <a:lnRef idx="2">
-              <a:schemeClr val="accent1">
-                <a:shade val="15000"/>
-              </a:schemeClr>
-            </a:lnRef>
-            <a:fillRef idx="1">
-              <a:schemeClr val="accent1"/>
-            </a:fillRef>
-            <a:effectRef idx="0">
-              <a:schemeClr val="accent1"/>
-            </a:effectRef>
-            <a:fontRef idx="minor">
-              <a:schemeClr val="lt1"/>
-            </a:fontRef>
-          </p:style>
-          <p:txBody>
-            <a:bodyPr rtlCol="0" anchor="t"/>
-            <a:lstStyle/>
-            <a:p>
-              <a:pPr algn="ctr"/>
-              <a:r>
-                <a:rPr lang="en-US" b="1" dirty="0">
-                  <a:solidFill>
-                    <a:schemeClr val="tx1"/>
-                  </a:solidFill>
-                </a:rPr>
-                <a:t>Specialty</a:t>
-              </a:r>
-            </a:p>
-          </p:txBody>
-        </p:sp>
-        <p:sp>
-          <p:nvSpPr>
-            <p:cNvPr id="7" name="Rectangle 6">
-              <a:extLst>
-                <a:ext uri="{FF2B5EF4-FFF2-40B4-BE49-F238E27FC236}">
-                  <a16:creationId xmlns:a16="http://schemas.microsoft.com/office/drawing/2014/main" id="{558D1BB3-2192-350C-C90C-4D8C2A5ECBBF}"/>
-                </a:ext>
-              </a:extLst>
-            </p:cNvPr>
-            <p:cNvSpPr/>
-            <p:nvPr/>
-          </p:nvSpPr>
-          <p:spPr>
-            <a:xfrm>
-              <a:off x="1014608" y="2104373"/>
-              <a:ext cx="1678488" cy="1215024"/>
-            </a:xfrm>
-            <a:prstGeom prst="rect">
-              <a:avLst/>
-            </a:prstGeom>
-            <a:solidFill>
-              <a:schemeClr val="bg2">
-                <a:lumMod val="90000"/>
-              </a:schemeClr>
-            </a:solidFill>
-          </p:spPr>
-          <p:style>
-            <a:lnRef idx="2">
-              <a:schemeClr val="accent1">
-                <a:shade val="15000"/>
-              </a:schemeClr>
-            </a:lnRef>
-            <a:fillRef idx="1">
-              <a:schemeClr val="accent1"/>
-            </a:fillRef>
-            <a:effectRef idx="0">
-              <a:schemeClr val="accent1"/>
-            </a:effectRef>
-            <a:fontRef idx="minor">
-              <a:schemeClr val="lt1"/>
-            </a:fontRef>
-          </p:style>
-          <p:txBody>
-            <a:bodyPr rtlCol="0" anchor="t"/>
-            <a:lstStyle/>
-            <a:p>
-              <a:r>
-                <a:rPr lang="en-US" sz="1200" b="1" dirty="0">
-                  <a:solidFill>
-                    <a:schemeClr val="tx1"/>
-                  </a:solidFill>
-                </a:rPr>
-                <a:t>Code (PK)</a:t>
-              </a:r>
-            </a:p>
-            <a:p>
-              <a:r>
-                <a:rPr lang="en-US" sz="1200" b="1" dirty="0">
-                  <a:solidFill>
-                    <a:schemeClr val="tx1"/>
-                  </a:solidFill>
-                </a:rPr>
-                <a:t>Specialization </a:t>
-              </a:r>
-            </a:p>
-            <a:p>
-              <a:r>
-                <a:rPr lang="en-US" sz="1200" b="1" dirty="0">
-                  <a:solidFill>
-                    <a:schemeClr val="tx1"/>
-                  </a:solidFill>
-                </a:rPr>
-                <a:t>Classification</a:t>
-              </a:r>
-            </a:p>
-            <a:p>
-              <a:r>
-                <a:rPr lang="en-US" sz="1200" b="1" dirty="0">
-                  <a:solidFill>
-                    <a:schemeClr val="tx1"/>
-                  </a:solidFill>
-                </a:rPr>
-                <a:t>Grouping</a:t>
-              </a:r>
-            </a:p>
-            <a:p>
-              <a:r>
-                <a:rPr lang="en-US" sz="1200" b="1" dirty="0">
-                  <a:solidFill>
-                    <a:schemeClr val="tx1"/>
-                  </a:solidFill>
-                </a:rPr>
-                <a:t>Description </a:t>
-              </a:r>
-            </a:p>
-            <a:p>
-              <a:endParaRPr lang="en-US" sz="1200" b="1" dirty="0">
-                <a:solidFill>
-                  <a:schemeClr val="tx1"/>
-                </a:solidFill>
-              </a:endParaRPr>
-            </a:p>
-            <a:p>
-              <a:endParaRPr lang="en-US" sz="1200" b="1" dirty="0">
-                <a:solidFill>
-                  <a:schemeClr val="tx1"/>
-                </a:solidFill>
-              </a:endParaRPr>
-            </a:p>
-            <a:p>
-              <a:endParaRPr lang="en-US" sz="1200" b="1" dirty="0">
-                <a:solidFill>
-                  <a:schemeClr val="tx1"/>
-                </a:solidFill>
-              </a:endParaRPr>
-            </a:p>
-          </p:txBody>
-        </p:sp>
-      </p:grpSp>
-      <p:grpSp>
-        <p:nvGrpSpPr>
-          <p:cNvPr id="18" name="Group 17">
-            <a:extLst>
-              <a:ext uri="{FF2B5EF4-FFF2-40B4-BE49-F238E27FC236}">
-                <a16:creationId xmlns:a16="http://schemas.microsoft.com/office/drawing/2014/main" id="{0CDA9506-10C9-6D83-FBD9-298BC55E2520}"/>
-              </a:ext>
-            </a:extLst>
-          </p:cNvPr>
-          <p:cNvGrpSpPr/>
-          <p:nvPr/>
-        </p:nvGrpSpPr>
-        <p:grpSpPr>
-          <a:xfrm>
-            <a:off x="4365218" y="1996219"/>
-            <a:ext cx="1678488" cy="1080603"/>
-            <a:chOff x="4207600" y="1690688"/>
-            <a:chExt cx="1678488" cy="1080603"/>
-          </a:xfrm>
-        </p:grpSpPr>
-        <p:sp>
-          <p:nvSpPr>
-            <p:cNvPr id="11" name="Rectangle 10">
-              <a:extLst>
-                <a:ext uri="{FF2B5EF4-FFF2-40B4-BE49-F238E27FC236}">
-                  <a16:creationId xmlns:a16="http://schemas.microsoft.com/office/drawing/2014/main" id="{7C247C78-C0AD-6C9D-FAC3-4E2778A864BF}"/>
-                </a:ext>
-              </a:extLst>
-            </p:cNvPr>
-            <p:cNvSpPr/>
-            <p:nvPr/>
-          </p:nvSpPr>
-          <p:spPr>
-            <a:xfrm>
-              <a:off x="4207600" y="1690688"/>
-              <a:ext cx="1678488" cy="413685"/>
-            </a:xfrm>
-            <a:prstGeom prst="rect">
-              <a:avLst/>
-            </a:prstGeom>
-            <a:solidFill>
-              <a:srgbClr val="FF0000"/>
-            </a:solidFill>
-          </p:spPr>
-          <p:style>
-            <a:lnRef idx="2">
-              <a:schemeClr val="accent1">
-                <a:shade val="15000"/>
-              </a:schemeClr>
-            </a:lnRef>
-            <a:fillRef idx="1">
-              <a:schemeClr val="accent1"/>
-            </a:fillRef>
-            <a:effectRef idx="0">
-              <a:schemeClr val="accent1"/>
-            </a:effectRef>
-            <a:fontRef idx="minor">
-              <a:schemeClr val="lt1"/>
-            </a:fontRef>
-          </p:style>
-          <p:txBody>
-            <a:bodyPr rtlCol="0" anchor="t"/>
-            <a:lstStyle/>
-            <a:p>
-              <a:pPr algn="ctr"/>
-              <a:r>
-                <a:rPr lang="en-US" b="1" dirty="0">
-                  <a:solidFill>
-                    <a:schemeClr val="tx1"/>
-                  </a:solidFill>
-                </a:rPr>
-                <a:t>Services</a:t>
-              </a:r>
-            </a:p>
-          </p:txBody>
-        </p:sp>
-        <p:sp>
-          <p:nvSpPr>
-            <p:cNvPr id="12" name="Rectangle 11">
-              <a:extLst>
-                <a:ext uri="{FF2B5EF4-FFF2-40B4-BE49-F238E27FC236}">
-                  <a16:creationId xmlns:a16="http://schemas.microsoft.com/office/drawing/2014/main" id="{9722205E-58DC-17E5-252B-B27CB0BB86EC}"/>
-                </a:ext>
-              </a:extLst>
-            </p:cNvPr>
-            <p:cNvSpPr/>
-            <p:nvPr/>
-          </p:nvSpPr>
-          <p:spPr>
-            <a:xfrm>
-              <a:off x="4207600" y="2104373"/>
-              <a:ext cx="1678488" cy="666918"/>
-            </a:xfrm>
-            <a:prstGeom prst="rect">
-              <a:avLst/>
-            </a:prstGeom>
-            <a:solidFill>
-              <a:srgbClr val="FF0000"/>
-            </a:solidFill>
-          </p:spPr>
-          <p:style>
-            <a:lnRef idx="2">
-              <a:schemeClr val="accent1">
-                <a:shade val="15000"/>
-              </a:schemeClr>
-            </a:lnRef>
-            <a:fillRef idx="1">
-              <a:schemeClr val="accent1"/>
-            </a:fillRef>
-            <a:effectRef idx="0">
-              <a:schemeClr val="accent1"/>
-            </a:effectRef>
-            <a:fontRef idx="minor">
-              <a:schemeClr val="lt1"/>
-            </a:fontRef>
-          </p:style>
-          <p:txBody>
-            <a:bodyPr rtlCol="0" anchor="t"/>
-            <a:lstStyle/>
-            <a:p>
-              <a:r>
-                <a:rPr lang="en-US" sz="1200" b="1" dirty="0">
-                  <a:solidFill>
-                    <a:schemeClr val="tx1"/>
-                  </a:solidFill>
-                </a:rPr>
-                <a:t>Service name</a:t>
-              </a:r>
-            </a:p>
-            <a:p>
-              <a:r>
-                <a:rPr lang="en-US" sz="1200" b="1" dirty="0">
-                  <a:solidFill>
-                    <a:schemeClr val="tx1"/>
-                  </a:solidFill>
-                </a:rPr>
-                <a:t>Service Description</a:t>
-              </a:r>
-            </a:p>
-            <a:p>
-              <a:endParaRPr lang="en-US" sz="1200" b="1" dirty="0">
-                <a:solidFill>
-                  <a:schemeClr val="tx1"/>
-                </a:solidFill>
-              </a:endParaRPr>
-            </a:p>
-            <a:p>
-              <a:endParaRPr lang="en-US" sz="1200" b="1" dirty="0">
-                <a:solidFill>
-                  <a:schemeClr val="tx1"/>
-                </a:solidFill>
-              </a:endParaRPr>
-            </a:p>
-          </p:txBody>
-        </p:sp>
-      </p:grpSp>
-      <p:cxnSp>
-        <p:nvCxnSpPr>
-          <p:cNvPr id="14" name="Straight Arrow Connector 13">
-            <a:extLst>
-              <a:ext uri="{FF2B5EF4-FFF2-40B4-BE49-F238E27FC236}">
-                <a16:creationId xmlns:a16="http://schemas.microsoft.com/office/drawing/2014/main" id="{48CB1425-3FD2-6817-E0B3-94474C6E4DD2}"/>
-              </a:ext>
-            </a:extLst>
-          </p:cNvPr>
-          <p:cNvCxnSpPr>
-            <a:cxnSpLocks/>
-            <a:stCxn id="7" idx="3"/>
-            <a:endCxn id="12" idx="1"/>
-          </p:cNvCxnSpPr>
-          <p:nvPr/>
-        </p:nvCxnSpPr>
         <p:spPr>
           <a:xfrm>
-            <a:off x="2693096" y="2711885"/>
-            <a:ext cx="1672122" cy="31478"/>
+            <a:off x="106680" y="0"/>
+            <a:ext cx="10515600" cy="671195"/>
           </a:xfrm>
-          <a:prstGeom prst="straightConnector1">
-            <a:avLst/>
-          </a:prstGeom>
-          <a:ln>
-            <a:tailEnd type="none"/>
-          </a:ln>
         </p:spPr>
-        <p:style>
-          <a:lnRef idx="2">
-            <a:schemeClr val="accent1"/>
-          </a:lnRef>
-          <a:fillRef idx="0">
-            <a:schemeClr val="accent1"/>
-          </a:fillRef>
-          <a:effectRef idx="1">
-            <a:schemeClr val="accent1"/>
-          </a:effectRef>
-          <a:fontRef idx="minor">
-            <a:schemeClr val="tx1"/>
-          </a:fontRef>
-        </p:style>
-      </p:cxnSp>
-      <p:sp>
-        <p:nvSpPr>
-          <p:cNvPr id="15" name="TextBox 14">
-            <a:extLst>
-              <a:ext uri="{FF2B5EF4-FFF2-40B4-BE49-F238E27FC236}">
-                <a16:creationId xmlns:a16="http://schemas.microsoft.com/office/drawing/2014/main" id="{7A47C5B3-1A07-BC5D-32B4-8EAB53945D11}"/>
-              </a:ext>
-            </a:extLst>
-          </p:cNvPr>
-          <p:cNvSpPr txBox="1"/>
+        <p:txBody>
+          <a:bodyPr>
+            <a:normAutofit fontScale="90000"/>
+          </a:bodyPr>
+          <a:lstStyle/>
+          <a:p>
+            <a:r>
+              <a:rPr lang="en-US" dirty="0"/>
+              <a:t>Core Component architecture</a:t>
+            </a:r>
+          </a:p>
+        </p:txBody>
+      </p:sp>
+      <p:sp>
+        <p:nvSpPr>
+          <p:cNvPr id="4" name="Rectangle 3">
+            <a:extLst>
+              <a:ext uri="{FF2B5EF4-FFF2-40B4-BE49-F238E27FC236}">
+                <a16:creationId xmlns:a16="http://schemas.microsoft.com/office/drawing/2014/main" id="{3D6956DF-1623-F1AF-C313-CF07F5C30AB9}"/>
+              </a:ext>
+            </a:extLst>
+          </p:cNvPr>
+          <p:cNvSpPr/>
           <p:nvPr/>
         </p:nvSpPr>
         <p:spPr>
           <a:xfrm>
-            <a:off x="3827744" y="2401959"/>
-            <a:ext cx="517642" cy="369332"/>
+            <a:off x="618282" y="1109554"/>
+            <a:ext cx="4903894" cy="5350933"/>
           </a:xfrm>
           <a:prstGeom prst="rect">
             <a:avLst/>
           </a:prstGeom>
-          <a:noFill/>
         </p:spPr>
-        <p:txBody>
-          <a:bodyPr wrap="none" rtlCol="0">
-            <a:spAutoFit/>
-          </a:bodyPr>
-          <a:lstStyle/>
-          <a:p>
-            <a:r>
-              <a:rPr lang="en-US" dirty="0"/>
-              <a:t>1..*</a:t>
-            </a:r>
-          </a:p>
-        </p:txBody>
-      </p:sp>
-      <p:sp>
-        <p:nvSpPr>
-          <p:cNvPr id="23" name="Rectangle 22">
-            <a:extLst>
-              <a:ext uri="{FF2B5EF4-FFF2-40B4-BE49-F238E27FC236}">
-                <a16:creationId xmlns:a16="http://schemas.microsoft.com/office/drawing/2014/main" id="{A8A26EE9-982A-8D62-0B87-C4A392681900}"/>
+        <p:style>
+          <a:lnRef idx="2">
+            <a:schemeClr val="accent1">
+              <a:shade val="15000"/>
+            </a:schemeClr>
+          </a:lnRef>
+          <a:fillRef idx="1">
+            <a:schemeClr val="accent1"/>
+          </a:fillRef>
+          <a:effectRef idx="0">
+            <a:schemeClr val="accent1"/>
+          </a:effectRef>
+          <a:fontRef idx="minor">
+            <a:schemeClr val="lt1"/>
+          </a:fontRef>
+        </p:style>
+        <p:txBody>
+          <a:bodyPr rtlCol="0" anchor="t"/>
+          <a:lstStyle/>
+          <a:p>
+            <a:pPr algn="ctr"/>
+            <a:r>
+              <a:rPr lang="en-US" sz="2800" dirty="0"/>
+              <a:t>Azure</a:t>
+            </a:r>
+          </a:p>
+          <a:p>
+            <a:pPr algn="ctr"/>
+            <a:endParaRPr lang="en-US" dirty="0"/>
+          </a:p>
+        </p:txBody>
+      </p:sp>
+      <p:sp>
+        <p:nvSpPr>
+          <p:cNvPr id="6" name="Rectangle 5">
+            <a:extLst>
+              <a:ext uri="{FF2B5EF4-FFF2-40B4-BE49-F238E27FC236}">
+                <a16:creationId xmlns:a16="http://schemas.microsoft.com/office/drawing/2014/main" id="{813C53A9-0024-0F0C-B39C-E06D56DB2D47}"/>
               </a:ext>
             </a:extLst>
           </p:cNvPr>
@@ -4165,15 +3676,16 @@
         </p:nvSpPr>
         <p:spPr>
           <a:xfrm>
-            <a:off x="1129429" y="3673001"/>
-            <a:ext cx="1678488" cy="413685"/>
+            <a:off x="724747" y="1706879"/>
+            <a:ext cx="2451946" cy="1205654"/>
           </a:xfrm>
           <a:prstGeom prst="rect">
             <a:avLst/>
           </a:prstGeom>
           <a:solidFill>
-            <a:schemeClr val="bg2">
-              <a:lumMod val="90000"/>
+            <a:schemeClr val="tx2">
+              <a:lumMod val="10000"/>
+              <a:lumOff val="90000"/>
             </a:schemeClr>
           </a:solidFill>
         </p:spPr>
@@ -4197,29 +3709,39 @@
           <a:bodyPr rtlCol="0" anchor="t"/>
           <a:lstStyle/>
           <a:p>
-            <a:pPr algn="ctr"/>
-            <a:r>
-              <a:rPr lang="en-US" b="1">
+            <a:r>
+              <a:rPr lang="en-US" sz="1400" dirty="0">
                 <a:solidFill>
                   <a:schemeClr val="tx1"/>
                 </a:solidFill>
               </a:rPr>
-              <a:t>Provider</a:t>
-            </a:r>
-            <a:endParaRPr lang="en-US" b="1" dirty="0">
-              <a:solidFill>
-                <a:schemeClr val="tx1"/>
-              </a:solidFill>
-            </a:endParaRPr>
-          </a:p>
-        </p:txBody>
-      </p:sp>
-      <p:sp>
-        <p:nvSpPr>
-          <p:cNvPr id="24" name="Rectangle 23">
-            <a:extLst>
-              <a:ext uri="{FF2B5EF4-FFF2-40B4-BE49-F238E27FC236}">
-                <a16:creationId xmlns:a16="http://schemas.microsoft.com/office/drawing/2014/main" id="{708D400A-BBB8-929A-2151-C5B0A083AED1}"/>
+              <a:t>Subscription: </a:t>
+            </a:r>
+            <a:r>
+              <a:rPr lang="en-US" sz="1400" dirty="0" err="1">
+                <a:solidFill>
+                  <a:schemeClr val="tx1"/>
+                </a:solidFill>
+              </a:rPr>
+              <a:t>FindCare</a:t>
+            </a:r>
+            <a:r>
+              <a:rPr lang="en-US" sz="1400" dirty="0">
+                <a:solidFill>
+                  <a:schemeClr val="tx1"/>
+                </a:solidFill>
+              </a:rPr>
+              <a:t>-AI</a:t>
+            </a:r>
+          </a:p>
+        </p:txBody>
+      </p:sp>
+      <p:sp>
+        <p:nvSpPr>
+          <p:cNvPr id="3" name="Rectangle 2">
+            <a:extLst>
+              <a:ext uri="{FF2B5EF4-FFF2-40B4-BE49-F238E27FC236}">
+                <a16:creationId xmlns:a16="http://schemas.microsoft.com/office/drawing/2014/main" id="{C2B25ECF-6118-ADE8-4119-369A8A3E6411}"/>
               </a:ext>
             </a:extLst>
           </p:cNvPr>
@@ -4228,17 +3750,12 @@
         </p:nvSpPr>
         <p:spPr>
           <a:xfrm>
-            <a:off x="1129429" y="4086686"/>
-            <a:ext cx="1678488" cy="1215024"/>
+            <a:off x="6263218" y="1194448"/>
+            <a:ext cx="3193765" cy="2831367"/>
           </a:xfrm>
           <a:prstGeom prst="rect">
             <a:avLst/>
           </a:prstGeom>
-          <a:solidFill>
-            <a:schemeClr val="bg2">
-              <a:lumMod val="90000"/>
-            </a:schemeClr>
-          </a:solidFill>
         </p:spPr>
         <p:style>
           <a:lnRef idx="2">
@@ -4260,82 +3777,742 @@
           <a:bodyPr rtlCol="0" anchor="t"/>
           <a:lstStyle/>
           <a:p>
-            <a:r>
-              <a:rPr lang="en-US" sz="1200" b="1" dirty="0">
-                <a:solidFill>
-                  <a:schemeClr val="tx1"/>
-                </a:solidFill>
-              </a:rPr>
-              <a:t>Code (PK)</a:t>
-            </a:r>
-          </a:p>
-          <a:p>
-            <a:r>
-              <a:rPr lang="en-US" sz="1200" b="1" dirty="0">
-                <a:solidFill>
-                  <a:schemeClr val="tx1"/>
-                </a:solidFill>
-              </a:rPr>
-              <a:t>Specialization </a:t>
-            </a:r>
-          </a:p>
-          <a:p>
-            <a:r>
-              <a:rPr lang="en-US" sz="1200" b="1" dirty="0">
-                <a:solidFill>
-                  <a:schemeClr val="tx1"/>
-                </a:solidFill>
-              </a:rPr>
-              <a:t>Classification</a:t>
-            </a:r>
-          </a:p>
-          <a:p>
-            <a:r>
-              <a:rPr lang="en-US" sz="1200" b="1" dirty="0">
-                <a:solidFill>
-                  <a:schemeClr val="tx1"/>
-                </a:solidFill>
-              </a:rPr>
-              <a:t>Grouping</a:t>
-            </a:r>
-          </a:p>
-          <a:p>
-            <a:r>
-              <a:rPr lang="en-US" sz="1200" b="1" dirty="0">
-                <a:solidFill>
-                  <a:schemeClr val="tx1"/>
-                </a:solidFill>
-              </a:rPr>
-              <a:t>Description </a:t>
-            </a:r>
-          </a:p>
-          <a:p>
-            <a:endParaRPr lang="en-US" sz="1200" b="1" dirty="0">
-              <a:solidFill>
-                <a:schemeClr val="tx1"/>
-              </a:solidFill>
-            </a:endParaRPr>
-          </a:p>
-          <a:p>
-            <a:endParaRPr lang="en-US" sz="1200" b="1" dirty="0">
-              <a:solidFill>
-                <a:schemeClr val="tx1"/>
-              </a:solidFill>
-            </a:endParaRPr>
-          </a:p>
-          <a:p>
-            <a:endParaRPr lang="en-US" sz="1200" b="1" dirty="0">
-              <a:solidFill>
-                <a:schemeClr val="tx1"/>
-              </a:solidFill>
-            </a:endParaRPr>
+            <a:pPr algn="ctr"/>
+            <a:r>
+              <a:rPr lang="en-US" sz="2800" dirty="0"/>
+              <a:t>Cloudflare</a:t>
+            </a:r>
+          </a:p>
+          <a:p>
+            <a:pPr algn="ctr"/>
+            <a:r>
+              <a:rPr lang="en-US" dirty="0"/>
+              <a:t>chatHealthy.ai</a:t>
+            </a:r>
+          </a:p>
+          <a:p>
+            <a:pPr algn="ctr"/>
+            <a:endParaRPr lang="en-US" dirty="0"/>
+          </a:p>
+        </p:txBody>
+      </p:sp>
+      <p:sp>
+        <p:nvSpPr>
+          <p:cNvPr id="8" name="Rectangle 7">
+            <a:extLst>
+              <a:ext uri="{FF2B5EF4-FFF2-40B4-BE49-F238E27FC236}">
+                <a16:creationId xmlns:a16="http://schemas.microsoft.com/office/drawing/2014/main" id="{0466C92B-A5C3-84E6-80AA-0DBADA80D8C3}"/>
+              </a:ext>
+            </a:extLst>
+          </p:cNvPr>
+          <p:cNvSpPr/>
+          <p:nvPr/>
+        </p:nvSpPr>
+        <p:spPr>
+          <a:xfrm>
+            <a:off x="6339430" y="4394029"/>
+            <a:ext cx="3332343" cy="2066458"/>
+          </a:xfrm>
+          <a:prstGeom prst="rect">
+            <a:avLst/>
+          </a:prstGeom>
+        </p:spPr>
+        <p:style>
+          <a:lnRef idx="2">
+            <a:schemeClr val="accent1">
+              <a:shade val="15000"/>
+            </a:schemeClr>
+          </a:lnRef>
+          <a:fillRef idx="1">
+            <a:schemeClr val="accent1"/>
+          </a:fillRef>
+          <a:effectRef idx="0">
+            <a:schemeClr val="accent1"/>
+          </a:effectRef>
+          <a:fontRef idx="minor">
+            <a:schemeClr val="lt1"/>
+          </a:fontRef>
+        </p:style>
+        <p:txBody>
+          <a:bodyPr rtlCol="0" anchor="t"/>
+          <a:lstStyle/>
+          <a:p>
+            <a:pPr algn="ctr"/>
+            <a:r>
+              <a:rPr lang="en-US" sz="2800"/>
+              <a:t>Mongo</a:t>
+            </a:r>
+            <a:endParaRPr lang="en-US" dirty="0"/>
+          </a:p>
+          <a:p>
+            <a:pPr algn="ctr"/>
+            <a:endParaRPr lang="en-US" dirty="0"/>
           </a:p>
         </p:txBody>
       </p:sp>
     </p:spTree>
     <p:extLst>
       <p:ext uri="{BB962C8B-B14F-4D97-AF65-F5344CB8AC3E}">
-        <p14:creationId xmlns:p14="http://schemas.microsoft.com/office/powerpoint/2010/main" val="3356390297"/>
+        <p14:creationId xmlns:p14="http://schemas.microsoft.com/office/powerpoint/2010/main" val="649129236"/>
+      </p:ext>
+    </p:extLst>
+  </p:cSld>
+  <p:clrMapOvr>
+    <a:masterClrMapping/>
+  </p:clrMapOvr>
+</p:sld>
+</file>
+
+<file path=ppt/slides/slide4.xml><?xml version="1.0" encoding="utf-8"?>
+<p:sld xmlns:a="http://schemas.openxmlformats.org/drawingml/2006/main" xmlns:r="http://schemas.openxmlformats.org/officeDocument/2006/relationships" xmlns:p="http://schemas.openxmlformats.org/presentationml/2006/main">
+  <p:cSld>
+    <p:spTree>
+      <p:nvGrpSpPr>
+        <p:cNvPr id="1" name=""/>
+        <p:cNvGrpSpPr/>
+        <p:nvPr/>
+      </p:nvGrpSpPr>
+      <p:grpSpPr>
+        <a:xfrm>
+          <a:off x="0" y="0"/>
+          <a:ext cx="0" cy="0"/>
+          <a:chOff x="0" y="0"/>
+          <a:chExt cx="0" cy="0"/>
+        </a:xfrm>
+      </p:grpSpPr>
+      <p:sp>
+        <p:nvSpPr>
+          <p:cNvPr id="2" name="Title 1">
+            <a:extLst>
+              <a:ext uri="{FF2B5EF4-FFF2-40B4-BE49-F238E27FC236}">
+                <a16:creationId xmlns:a16="http://schemas.microsoft.com/office/drawing/2014/main" id="{5007F60F-8368-905B-9F42-75E39B38819B}"/>
+              </a:ext>
+            </a:extLst>
+          </p:cNvPr>
+          <p:cNvSpPr>
+            <a:spLocks noGrp="1"/>
+          </p:cNvSpPr>
+          <p:nvPr>
+            <p:ph type="title"/>
+          </p:nvPr>
+        </p:nvSpPr>
+        <p:spPr/>
+        <p:txBody>
+          <a:bodyPr/>
+          <a:lstStyle/>
+          <a:p>
+            <a:r>
+              <a:rPr lang="en-US" dirty="0"/>
+              <a:t>Commercial application of web site</a:t>
+            </a:r>
+          </a:p>
+        </p:txBody>
+      </p:sp>
+      <p:sp>
+        <p:nvSpPr>
+          <p:cNvPr id="3" name="Content Placeholder 2">
+            <a:extLst>
+              <a:ext uri="{FF2B5EF4-FFF2-40B4-BE49-F238E27FC236}">
+                <a16:creationId xmlns:a16="http://schemas.microsoft.com/office/drawing/2014/main" id="{DF32CF06-6CF1-3D56-A57E-AD0B5EAE779B}"/>
+              </a:ext>
+            </a:extLst>
+          </p:cNvPr>
+          <p:cNvSpPr>
+            <a:spLocks noGrp="1"/>
+          </p:cNvSpPr>
+          <p:nvPr>
+            <p:ph idx="1"/>
+          </p:nvPr>
+        </p:nvSpPr>
+        <p:spPr/>
+        <p:txBody>
+          <a:bodyPr/>
+          <a:lstStyle/>
+          <a:p>
+            <a:r>
+              <a:rPr lang="en-US" dirty="0"/>
+              <a:t>As of now this is thought of as an AI portfolio piece by Skip Snow without commercial implications.</a:t>
+            </a:r>
+          </a:p>
+        </p:txBody>
+      </p:sp>
+    </p:spTree>
+    <p:extLst>
+      <p:ext uri="{BB962C8B-B14F-4D97-AF65-F5344CB8AC3E}">
+        <p14:creationId xmlns:p14="http://schemas.microsoft.com/office/powerpoint/2010/main" val="2505143561"/>
+      </p:ext>
+    </p:extLst>
+  </p:cSld>
+  <p:clrMapOvr>
+    <a:masterClrMapping/>
+  </p:clrMapOvr>
+</p:sld>
+</file>
+
+<file path=ppt/slides/slide5.xml><?xml version="1.0" encoding="utf-8"?>
+<p:sld xmlns:a="http://schemas.openxmlformats.org/drawingml/2006/main" xmlns:r="http://schemas.openxmlformats.org/officeDocument/2006/relationships" xmlns:p="http://schemas.openxmlformats.org/presentationml/2006/main">
+  <p:cSld>
+    <p:spTree>
+      <p:nvGrpSpPr>
+        <p:cNvPr id="1" name=""/>
+        <p:cNvGrpSpPr/>
+        <p:nvPr/>
+      </p:nvGrpSpPr>
+      <p:grpSpPr>
+        <a:xfrm>
+          <a:off x="0" y="0"/>
+          <a:ext cx="0" cy="0"/>
+          <a:chOff x="0" y="0"/>
+          <a:chExt cx="0" cy="0"/>
+        </a:xfrm>
+      </p:grpSpPr>
+      <p:sp>
+        <p:nvSpPr>
+          <p:cNvPr id="2" name="Title 1">
+            <a:extLst>
+              <a:ext uri="{FF2B5EF4-FFF2-40B4-BE49-F238E27FC236}">
+                <a16:creationId xmlns:a16="http://schemas.microsoft.com/office/drawing/2014/main" id="{191ADB60-E9B2-1519-D538-28CD02C88F06}"/>
+              </a:ext>
+            </a:extLst>
+          </p:cNvPr>
+          <p:cNvSpPr>
+            <a:spLocks noGrp="1"/>
+          </p:cNvSpPr>
+          <p:nvPr>
+            <p:ph type="title"/>
+          </p:nvPr>
+        </p:nvSpPr>
+        <p:spPr/>
+        <p:txBody>
+          <a:bodyPr/>
+          <a:lstStyle/>
+          <a:p>
+            <a:r>
+              <a:rPr lang="en-US" dirty="0"/>
+              <a:t>Data Pipelines</a:t>
+            </a:r>
+          </a:p>
+        </p:txBody>
+      </p:sp>
+      <p:sp>
+        <p:nvSpPr>
+          <p:cNvPr id="3" name="Content Placeholder 2">
+            <a:extLst>
+              <a:ext uri="{FF2B5EF4-FFF2-40B4-BE49-F238E27FC236}">
+                <a16:creationId xmlns:a16="http://schemas.microsoft.com/office/drawing/2014/main" id="{B36CE97F-0AEB-E9C9-CD62-E88A8E13296E}"/>
+              </a:ext>
+            </a:extLst>
+          </p:cNvPr>
+          <p:cNvSpPr>
+            <a:spLocks noGrp="1"/>
+          </p:cNvSpPr>
+          <p:nvPr>
+            <p:ph idx="1"/>
+          </p:nvPr>
+        </p:nvSpPr>
+        <p:spPr/>
+        <p:txBody>
+          <a:bodyPr/>
+          <a:lstStyle/>
+          <a:p>
+            <a:r>
+              <a:rPr lang="en-US" dirty="0"/>
+              <a:t>There are several data sources that contribute to this effort and they must be kept fresh. This means that on a schedule the data must be refreshed by the pipeline without human oversight.</a:t>
+            </a:r>
+          </a:p>
+          <a:p>
+            <a:r>
+              <a:rPr lang="en-US" dirty="0"/>
+              <a:t>Major data sources</a:t>
+            </a:r>
+          </a:p>
+          <a:p>
+            <a:pPr lvl="1"/>
+            <a:r>
+              <a:rPr lang="en-US" dirty="0"/>
+              <a:t>National provider data</a:t>
+            </a:r>
+          </a:p>
+          <a:p>
+            <a:pPr lvl="2"/>
+            <a:endParaRPr lang="en-US" dirty="0"/>
+          </a:p>
+        </p:txBody>
+      </p:sp>
+    </p:spTree>
+    <p:extLst>
+      <p:ext uri="{BB962C8B-B14F-4D97-AF65-F5344CB8AC3E}">
+        <p14:creationId xmlns:p14="http://schemas.microsoft.com/office/powerpoint/2010/main" val="2213259797"/>
+      </p:ext>
+    </p:extLst>
+  </p:cSld>
+  <p:clrMapOvr>
+    <a:masterClrMapping/>
+  </p:clrMapOvr>
+</p:sld>
+</file>
+
+<file path=ppt/slides/slide6.xml><?xml version="1.0" encoding="utf-8"?>
+<p:sld xmlns:a="http://schemas.openxmlformats.org/drawingml/2006/main" xmlns:r="http://schemas.openxmlformats.org/officeDocument/2006/relationships" xmlns:p="http://schemas.openxmlformats.org/presentationml/2006/main">
+  <p:cSld>
+    <p:spTree>
+      <p:nvGrpSpPr>
+        <p:cNvPr id="1" name=""/>
+        <p:cNvGrpSpPr/>
+        <p:nvPr/>
+      </p:nvGrpSpPr>
+      <p:grpSpPr>
+        <a:xfrm>
+          <a:off x="0" y="0"/>
+          <a:ext cx="0" cy="0"/>
+          <a:chOff x="0" y="0"/>
+          <a:chExt cx="0" cy="0"/>
+        </a:xfrm>
+      </p:grpSpPr>
+      <p:sp>
+        <p:nvSpPr>
+          <p:cNvPr id="4" name="Title 3">
+            <a:extLst>
+              <a:ext uri="{FF2B5EF4-FFF2-40B4-BE49-F238E27FC236}">
+                <a16:creationId xmlns:a16="http://schemas.microsoft.com/office/drawing/2014/main" id="{2B7E0430-9266-C61F-62F1-66ACEFBC489D}"/>
+              </a:ext>
+            </a:extLst>
+          </p:cNvPr>
+          <p:cNvSpPr>
+            <a:spLocks noGrp="1"/>
+          </p:cNvSpPr>
+          <p:nvPr>
+            <p:ph type="title"/>
+          </p:nvPr>
+        </p:nvSpPr>
+        <p:spPr/>
+        <p:txBody>
+          <a:bodyPr/>
+          <a:lstStyle/>
+          <a:p>
+            <a:r>
+              <a:rPr lang="en-US" dirty="0"/>
+              <a:t>Appendix</a:t>
+            </a:r>
+          </a:p>
+        </p:txBody>
+      </p:sp>
+      <p:sp>
+        <p:nvSpPr>
+          <p:cNvPr id="5" name="Content Placeholder 4">
+            <a:extLst>
+              <a:ext uri="{FF2B5EF4-FFF2-40B4-BE49-F238E27FC236}">
+                <a16:creationId xmlns:a16="http://schemas.microsoft.com/office/drawing/2014/main" id="{4ED5FF93-4C27-E8C8-FFF0-5BFD07E49236}"/>
+              </a:ext>
+            </a:extLst>
+          </p:cNvPr>
+          <p:cNvSpPr>
+            <a:spLocks noGrp="1"/>
+          </p:cNvSpPr>
+          <p:nvPr>
+            <p:ph idx="1"/>
+          </p:nvPr>
+        </p:nvSpPr>
+        <p:spPr/>
+        <p:txBody>
+          <a:bodyPr/>
+          <a:lstStyle/>
+          <a:p>
+            <a:endParaRPr lang="en-US"/>
+          </a:p>
+        </p:txBody>
+      </p:sp>
+    </p:spTree>
+    <p:extLst>
+      <p:ext uri="{BB962C8B-B14F-4D97-AF65-F5344CB8AC3E}">
+        <p14:creationId xmlns:p14="http://schemas.microsoft.com/office/powerpoint/2010/main" val="997819748"/>
+      </p:ext>
+    </p:extLst>
+  </p:cSld>
+  <p:clrMapOvr>
+    <a:masterClrMapping/>
+  </p:clrMapOvr>
+</p:sld>
+</file>
+
+<file path=ppt/slides/slide7.xml><?xml version="1.0" encoding="utf-8"?>
+<p:sld xmlns:a="http://schemas.openxmlformats.org/drawingml/2006/main" xmlns:r="http://schemas.openxmlformats.org/officeDocument/2006/relationships" xmlns:p="http://schemas.openxmlformats.org/presentationml/2006/main">
+  <p:cSld>
+    <p:spTree>
+      <p:nvGrpSpPr>
+        <p:cNvPr id="1" name=""/>
+        <p:cNvGrpSpPr/>
+        <p:nvPr/>
+      </p:nvGrpSpPr>
+      <p:grpSpPr>
+        <a:xfrm>
+          <a:off x="0" y="0"/>
+          <a:ext cx="0" cy="0"/>
+          <a:chOff x="0" y="0"/>
+          <a:chExt cx="0" cy="0"/>
+        </a:xfrm>
+      </p:grpSpPr>
+      <p:sp>
+        <p:nvSpPr>
+          <p:cNvPr id="2" name="Title 1">
+            <a:extLst>
+              <a:ext uri="{FF2B5EF4-FFF2-40B4-BE49-F238E27FC236}">
+                <a16:creationId xmlns:a16="http://schemas.microsoft.com/office/drawing/2014/main" id="{5AAD0D87-F2B0-8B2D-EF2E-46095805DFAF}"/>
+              </a:ext>
+            </a:extLst>
+          </p:cNvPr>
+          <p:cNvSpPr>
+            <a:spLocks noGrp="1"/>
+          </p:cNvSpPr>
+          <p:nvPr>
+            <p:ph type="title"/>
+          </p:nvPr>
+        </p:nvSpPr>
+        <p:spPr>
+          <a:xfrm>
+            <a:off x="838200" y="365126"/>
+            <a:ext cx="10515600" cy="840528"/>
+          </a:xfrm>
+        </p:spPr>
+        <p:txBody>
+          <a:bodyPr/>
+          <a:lstStyle/>
+          <a:p>
+            <a:r>
+              <a:rPr lang="en-US" dirty="0"/>
+              <a:t>Azure deployment Architecture</a:t>
+            </a:r>
+          </a:p>
+        </p:txBody>
+      </p:sp>
+      <p:sp>
+        <p:nvSpPr>
+          <p:cNvPr id="3" name="Content Placeholder 2">
+            <a:extLst>
+              <a:ext uri="{FF2B5EF4-FFF2-40B4-BE49-F238E27FC236}">
+                <a16:creationId xmlns:a16="http://schemas.microsoft.com/office/drawing/2014/main" id="{B57A65A2-2228-D79B-C01D-3264AAB9155D}"/>
+              </a:ext>
+            </a:extLst>
+          </p:cNvPr>
+          <p:cNvSpPr>
+            <a:spLocks noGrp="1"/>
+          </p:cNvSpPr>
+          <p:nvPr>
+            <p:ph idx="1"/>
+          </p:nvPr>
+        </p:nvSpPr>
+        <p:spPr>
+          <a:xfrm>
+            <a:off x="458894" y="1541145"/>
+            <a:ext cx="3787987" cy="4351338"/>
+          </a:xfrm>
+        </p:spPr>
+        <p:txBody>
+          <a:bodyPr>
+            <a:normAutofit fontScale="32500" lnSpcReduction="20000"/>
+          </a:bodyPr>
+          <a:lstStyle/>
+          <a:p>
+            <a:r>
+              <a:rPr lang="en-US"/>
+              <a:t>Subscription: ChatHealthy</a:t>
+            </a:r>
+          </a:p>
+          <a:p>
+            <a:r>
+              <a:rPr lang="en-US"/>
+              <a:t>└── Resource Group: ChatHealthyDataPipelines</a:t>
+            </a:r>
+          </a:p>
+          <a:p>
+            <a:r>
+              <a:rPr lang="en-US"/>
+              <a:t>    ├── Tag: environment → dev | qa | prod</a:t>
+            </a:r>
+          </a:p>
+          <a:p>
+            <a:r>
+              <a:rPr lang="en-US"/>
+              <a:t>    ├── Tag: version     → 1.0.0</a:t>
+            </a:r>
+          </a:p>
+          <a:p>
+            <a:r>
+              <a:rPr lang="en-US"/>
+              <a:t>    │</a:t>
+            </a:r>
+          </a:p>
+          <a:p>
+            <a:r>
+              <a:rPr lang="en-US"/>
+              <a:t>    ├── Namespace: PipelineInfrastructure [SHARED]</a:t>
+            </a:r>
+          </a:p>
+          <a:p>
+            <a:r>
+              <a:rPr lang="en-US"/>
+              <a:t>    │   ├── Storage Account [SHARED]</a:t>
+            </a:r>
+          </a:p>
+          <a:p>
+            <a:r>
+              <a:rPr lang="en-US"/>
+              <a:t>    │   │   └── Blob Container</a:t>
+            </a:r>
+          </a:p>
+          <a:p>
+            <a:r>
+              <a:rPr lang="en-US"/>
+              <a:t>    │   │       └── Tag: environment → dev</a:t>
+            </a:r>
+          </a:p>
+          <a:p>
+            <a:r>
+              <a:rPr lang="en-US"/>
+              <a:t>    │   ├── Virtual Network / Subnet [SHARED]</a:t>
+            </a:r>
+          </a:p>
+          <a:p>
+            <a:r>
+              <a:rPr lang="en-US"/>
+              <a:t>    │   └── Key Vault [SHARED]</a:t>
+            </a:r>
+          </a:p>
+          <a:p>
+            <a:r>
+              <a:rPr lang="en-US"/>
+              <a:t>    │</a:t>
+            </a:r>
+          </a:p>
+          <a:p>
+            <a:r>
+              <a:rPr lang="en-US"/>
+              <a:t>    └── Namespace: ProviderDataPipelineApp</a:t>
+            </a:r>
+          </a:p>
+          <a:p>
+            <a:r>
+              <a:rPr lang="en-US"/>
+              <a:t>        ├── Function App: FetchAndDistributeProviderData</a:t>
+            </a:r>
+          </a:p>
+          <a:p>
+            <a:r>
+              <a:rPr lang="en-US"/>
+              <a:t>        │   └── Tag: environment → dev</a:t>
+            </a:r>
+          </a:p>
+          <a:p>
+            <a:r>
+              <a:rPr lang="en-US"/>
+              <a:t>        ├── Function App: NPDBDataToMongo</a:t>
+            </a:r>
+          </a:p>
+          <a:p>
+            <a:r>
+              <a:rPr lang="en-US"/>
+              <a:t>        │   └── Tag: environment → dev</a:t>
+            </a:r>
+          </a:p>
+          <a:p>
+            <a:r>
+              <a:rPr lang="en-US"/>
+              <a:t>        └── Storage → ref: PipelineInfrastructure</a:t>
+            </a:r>
+            <a:endParaRPr lang="en-US" dirty="0"/>
+          </a:p>
+        </p:txBody>
+      </p:sp>
+      <p:sp>
+        <p:nvSpPr>
+          <p:cNvPr id="4" name="TextBox 3">
+            <a:extLst>
+              <a:ext uri="{FF2B5EF4-FFF2-40B4-BE49-F238E27FC236}">
+                <a16:creationId xmlns:a16="http://schemas.microsoft.com/office/drawing/2014/main" id="{D7F92A63-5EF3-52A3-0F23-0077A9ABC82E}"/>
+              </a:ext>
+            </a:extLst>
+          </p:cNvPr>
+          <p:cNvSpPr txBox="1"/>
+          <p:nvPr/>
+        </p:nvSpPr>
+        <p:spPr>
+          <a:xfrm>
+            <a:off x="3578012" y="1541145"/>
+            <a:ext cx="7775788" cy="4893647"/>
+          </a:xfrm>
+          <a:prstGeom prst="rect">
+            <a:avLst/>
+          </a:prstGeom>
+          <a:noFill/>
+        </p:spPr>
+        <p:txBody>
+          <a:bodyPr wrap="square" rtlCol="0">
+            <a:spAutoFit/>
+          </a:bodyPr>
+          <a:lstStyle/>
+          <a:p>
+            <a:pPr marL="285750" indent="-285750">
+              <a:buFont typeface="Arial" panose="020B0604020202020204" pitchFamily="34" charset="0"/>
+              <a:buChar char="•"/>
+            </a:pPr>
+            <a:r>
+              <a:rPr lang="en-US" sz="2400" dirty="0">
+                <a:solidFill>
+                  <a:schemeClr val="tx1">
+                    <a:lumMod val="65000"/>
+                    <a:lumOff val="35000"/>
+                  </a:schemeClr>
+                </a:solidFill>
+              </a:rPr>
+              <a:t>The use of deployment facts in a predictable matter allow for a business to respond to changes to its operating model. </a:t>
+            </a:r>
+          </a:p>
+          <a:p>
+            <a:pPr marL="742950" lvl="1" indent="-285750">
+              <a:buFont typeface="Arial" panose="020B0604020202020204" pitchFamily="34" charset="0"/>
+              <a:buChar char="•"/>
+            </a:pPr>
+            <a:r>
+              <a:rPr lang="en-US" sz="2400" dirty="0">
+                <a:solidFill>
+                  <a:schemeClr val="tx1">
+                    <a:lumMod val="65000"/>
+                    <a:lumOff val="35000"/>
+                  </a:schemeClr>
+                </a:solidFill>
+              </a:rPr>
+              <a:t>Resource groups can cross all boundaries but should be </a:t>
+            </a:r>
+            <a:r>
+              <a:rPr lang="en-US" sz="2400" dirty="0" err="1">
+                <a:solidFill>
+                  <a:schemeClr val="tx1">
+                    <a:lumMod val="65000"/>
+                    <a:lumOff val="35000"/>
+                  </a:schemeClr>
+                </a:solidFill>
+              </a:rPr>
+              <a:t>maped</a:t>
+            </a:r>
+            <a:r>
+              <a:rPr lang="en-US" sz="2400" dirty="0">
+                <a:solidFill>
+                  <a:schemeClr val="tx1">
+                    <a:lumMod val="65000"/>
+                    <a:lumOff val="35000"/>
+                  </a:schemeClr>
+                </a:solidFill>
+              </a:rPr>
+              <a:t> to an accounting and HR model. </a:t>
+            </a:r>
+          </a:p>
+          <a:p>
+            <a:pPr marL="742950" lvl="1" indent="-285750">
+              <a:buFont typeface="Arial" panose="020B0604020202020204" pitchFamily="34" charset="0"/>
+              <a:buChar char="•"/>
+            </a:pPr>
+            <a:r>
+              <a:rPr lang="en-US" sz="2400" dirty="0">
+                <a:solidFill>
+                  <a:schemeClr val="tx1">
+                    <a:lumMod val="65000"/>
+                    <a:lumOff val="35000"/>
+                  </a:schemeClr>
+                </a:solidFill>
+              </a:rPr>
+              <a:t>Other resource groups to be created are and two are planed, </a:t>
+            </a:r>
+          </a:p>
+          <a:p>
+            <a:pPr marL="1200150" lvl="2" indent="-285750">
+              <a:buFont typeface="Arial" panose="020B0604020202020204" pitchFamily="34" charset="0"/>
+              <a:buChar char="•"/>
+            </a:pPr>
+            <a:r>
+              <a:rPr lang="en-US" sz="2400" dirty="0">
+                <a:solidFill>
+                  <a:schemeClr val="tx1">
+                    <a:lumMod val="65000"/>
+                    <a:lumOff val="35000"/>
+                  </a:schemeClr>
+                </a:solidFill>
+              </a:rPr>
+              <a:t>Chat </a:t>
+            </a:r>
+            <a:r>
+              <a:rPr lang="en-US" sz="2400" dirty="0" err="1">
+                <a:solidFill>
+                  <a:schemeClr val="tx1">
+                    <a:lumMod val="65000"/>
+                    <a:lumOff val="35000"/>
+                  </a:schemeClr>
+                </a:solidFill>
+              </a:rPr>
+              <a:t>HealthyTest</a:t>
+            </a:r>
+            <a:r>
+              <a:rPr lang="en-US" sz="2400" dirty="0">
+                <a:solidFill>
+                  <a:schemeClr val="tx1">
+                    <a:lumMod val="65000"/>
+                    <a:lumOff val="35000"/>
+                  </a:schemeClr>
+                </a:solidFill>
+              </a:rPr>
+              <a:t>,  This is where the accuracy  chat Healthy's responses are tested against Boolean based criteria. And design decisions are revisited. </a:t>
+            </a:r>
+          </a:p>
+          <a:p>
+            <a:pPr marL="1200150" lvl="2" indent="-285750">
+              <a:buFont typeface="Arial" panose="020B0604020202020204" pitchFamily="34" charset="0"/>
+              <a:buChar char="•"/>
+            </a:pPr>
+            <a:r>
+              <a:rPr lang="en-US" sz="2400" dirty="0">
+                <a:solidFill>
+                  <a:schemeClr val="tx1">
+                    <a:lumMod val="65000"/>
+                    <a:lumOff val="35000"/>
+                  </a:schemeClr>
+                </a:solidFill>
+              </a:rPr>
+              <a:t>Find Care Run Time application</a:t>
+            </a:r>
+          </a:p>
+          <a:p>
+            <a:pPr marL="742950" lvl="1" indent="-285750">
+              <a:buFont typeface="Arial" panose="020B0604020202020204" pitchFamily="34" charset="0"/>
+              <a:buChar char="•"/>
+            </a:pPr>
+            <a:r>
+              <a:rPr lang="en-US" sz="2400" dirty="0">
+                <a:solidFill>
+                  <a:schemeClr val="tx1">
+                    <a:lumMod val="65000"/>
+                    <a:lumOff val="35000"/>
+                  </a:schemeClr>
+                </a:solidFill>
+              </a:rPr>
+              <a:t>There is only 1 azure subscription</a:t>
+            </a:r>
+            <a:r>
+              <a:rPr lang="en-US" dirty="0">
+                <a:solidFill>
+                  <a:schemeClr val="tx1">
+                    <a:lumMod val="65000"/>
+                    <a:lumOff val="35000"/>
+                  </a:schemeClr>
+                </a:solidFill>
+              </a:rPr>
+              <a:t>. </a:t>
+            </a:r>
+          </a:p>
+        </p:txBody>
+      </p:sp>
+    </p:spTree>
+    <p:extLst>
+      <p:ext uri="{BB962C8B-B14F-4D97-AF65-F5344CB8AC3E}">
+        <p14:creationId xmlns:p14="http://schemas.microsoft.com/office/powerpoint/2010/main" val="1988505791"/>
       </p:ext>
     </p:extLst>
   </p:cSld>

</xml_diff>

<commit_message>
Restructure repo as ChatHealthyRepo monorepo
- Renamed HuggingBearCode/ → ConversationalUX/ (Layer 1)
- Renamed AzureCode/ → DataPipelines/ (Layer 2)
- Added Shared/ for common utilities (ChatHealthyMongoUtilities)
- Merged ChatHealthyDataPipelines code into Code/DataPipelines/
- Merged ChatHealthyWebSite into Website/
- Added FindCareDocumentation content to Documentation/
- Added deploy-pipelines.yml and test.yml GitHub Actions workflows
- Updated deploy-hf.yml paths to ConversationalUX
- Updated .gitignore: exclude notebooks, venvs, pycache, .claude/
- Updated CLAUDE.md to reflect full new structure

Co-Authored-By: Claude Sonnet 4.6 <noreply@anthropic.com>
</commit_message>
<xml_diff>
--- a/Documentation/ProjectArchitecture.pptx
+++ b/Documentation/ProjectArchitecture.pptx
@@ -6,12 +6,15 @@
   </p:sldMasterIdLst>
   <p:sldIdLst>
     <p:sldId id="256" r:id="rId2"/>
-    <p:sldId id="259" r:id="rId3"/>
-    <p:sldId id="262" r:id="rId4"/>
-    <p:sldId id="260" r:id="rId5"/>
-    <p:sldId id="261" r:id="rId6"/>
-    <p:sldId id="263" r:id="rId7"/>
-    <p:sldId id="264" r:id="rId8"/>
+    <p:sldId id="268" r:id="rId3"/>
+    <p:sldId id="259" r:id="rId4"/>
+    <p:sldId id="262" r:id="rId5"/>
+    <p:sldId id="266" r:id="rId6"/>
+    <p:sldId id="265" r:id="rId7"/>
+    <p:sldId id="260" r:id="rId8"/>
+    <p:sldId id="261" r:id="rId9"/>
+    <p:sldId id="263" r:id="rId10"/>
+    <p:sldId id="264" r:id="rId11"/>
   </p:sldIdLst>
   <p:sldSz cx="12192000" cy="6858000"/>
   <p:notesSz cx="6858000" cy="9144000"/>
@@ -265,7 +268,7 @@
           <a:p>
             <a:fld id="{82B1C2C3-D437-4CB5-914C-06113AC135BA}" type="datetimeFigureOut">
               <a:rPr lang="en-US" smtClean="0"/>
-              <a:t>3/2/2026</a:t>
+              <a:t>3/12/2026</a:t>
             </a:fld>
             <a:endParaRPr lang="en-US"/>
           </a:p>
@@ -463,7 +466,7 @@
           <a:p>
             <a:fld id="{82B1C2C3-D437-4CB5-914C-06113AC135BA}" type="datetimeFigureOut">
               <a:rPr lang="en-US" smtClean="0"/>
-              <a:t>3/2/2026</a:t>
+              <a:t>3/12/2026</a:t>
             </a:fld>
             <a:endParaRPr lang="en-US"/>
           </a:p>
@@ -671,7 +674,7 @@
           <a:p>
             <a:fld id="{82B1C2C3-D437-4CB5-914C-06113AC135BA}" type="datetimeFigureOut">
               <a:rPr lang="en-US" smtClean="0"/>
-              <a:t>3/2/2026</a:t>
+              <a:t>3/12/2026</a:t>
             </a:fld>
             <a:endParaRPr lang="en-US"/>
           </a:p>
@@ -869,7 +872,7 @@
           <a:p>
             <a:fld id="{82B1C2C3-D437-4CB5-914C-06113AC135BA}" type="datetimeFigureOut">
               <a:rPr lang="en-US" smtClean="0"/>
-              <a:t>3/2/2026</a:t>
+              <a:t>3/12/2026</a:t>
             </a:fld>
             <a:endParaRPr lang="en-US"/>
           </a:p>
@@ -1144,7 +1147,7 @@
           <a:p>
             <a:fld id="{82B1C2C3-D437-4CB5-914C-06113AC135BA}" type="datetimeFigureOut">
               <a:rPr lang="en-US" smtClean="0"/>
-              <a:t>3/2/2026</a:t>
+              <a:t>3/12/2026</a:t>
             </a:fld>
             <a:endParaRPr lang="en-US"/>
           </a:p>
@@ -1409,7 +1412,7 @@
           <a:p>
             <a:fld id="{82B1C2C3-D437-4CB5-914C-06113AC135BA}" type="datetimeFigureOut">
               <a:rPr lang="en-US" smtClean="0"/>
-              <a:t>3/2/2026</a:t>
+              <a:t>3/12/2026</a:t>
             </a:fld>
             <a:endParaRPr lang="en-US"/>
           </a:p>
@@ -1821,7 +1824,7 @@
           <a:p>
             <a:fld id="{82B1C2C3-D437-4CB5-914C-06113AC135BA}" type="datetimeFigureOut">
               <a:rPr lang="en-US" smtClean="0"/>
-              <a:t>3/2/2026</a:t>
+              <a:t>3/12/2026</a:t>
             </a:fld>
             <a:endParaRPr lang="en-US"/>
           </a:p>
@@ -1962,7 +1965,7 @@
           <a:p>
             <a:fld id="{82B1C2C3-D437-4CB5-914C-06113AC135BA}" type="datetimeFigureOut">
               <a:rPr lang="en-US" smtClean="0"/>
-              <a:t>3/2/2026</a:t>
+              <a:t>3/12/2026</a:t>
             </a:fld>
             <a:endParaRPr lang="en-US"/>
           </a:p>
@@ -2075,7 +2078,7 @@
           <a:p>
             <a:fld id="{82B1C2C3-D437-4CB5-914C-06113AC135BA}" type="datetimeFigureOut">
               <a:rPr lang="en-US" smtClean="0"/>
-              <a:t>3/2/2026</a:t>
+              <a:t>3/12/2026</a:t>
             </a:fld>
             <a:endParaRPr lang="en-US"/>
           </a:p>
@@ -2386,7 +2389,7 @@
           <a:p>
             <a:fld id="{82B1C2C3-D437-4CB5-914C-06113AC135BA}" type="datetimeFigureOut">
               <a:rPr lang="en-US" smtClean="0"/>
-              <a:t>3/2/2026</a:t>
+              <a:t>3/12/2026</a:t>
             </a:fld>
             <a:endParaRPr lang="en-US"/>
           </a:p>
@@ -2674,7 +2677,7 @@
           <a:p>
             <a:fld id="{82B1C2C3-D437-4CB5-914C-06113AC135BA}" type="datetimeFigureOut">
               <a:rPr lang="en-US" smtClean="0"/>
-              <a:t>3/2/2026</a:t>
+              <a:t>3/12/2026</a:t>
             </a:fld>
             <a:endParaRPr lang="en-US"/>
           </a:p>
@@ -2915,7 +2918,7 @@
           <a:p>
             <a:fld id="{82B1C2C3-D437-4CB5-914C-06113AC135BA}" type="datetimeFigureOut">
               <a:rPr lang="en-US" smtClean="0"/>
-              <a:t>3/2/2026</a:t>
+              <a:t>3/12/2026</a:t>
             </a:fld>
             <a:endParaRPr lang="en-US"/>
           </a:p>
@@ -3418,6 +3421,393 @@
 </p:sld>
 </file>
 
+<file path=ppt/slides/slide10.xml><?xml version="1.0" encoding="utf-8"?>
+<p:sld xmlns:a="http://schemas.openxmlformats.org/drawingml/2006/main" xmlns:r="http://schemas.openxmlformats.org/officeDocument/2006/relationships" xmlns:p="http://schemas.openxmlformats.org/presentationml/2006/main">
+  <p:cSld>
+    <p:spTree>
+      <p:nvGrpSpPr>
+        <p:cNvPr id="1" name=""/>
+        <p:cNvGrpSpPr/>
+        <p:nvPr/>
+      </p:nvGrpSpPr>
+      <p:grpSpPr>
+        <a:xfrm>
+          <a:off x="0" y="0"/>
+          <a:ext cx="0" cy="0"/>
+          <a:chOff x="0" y="0"/>
+          <a:chExt cx="0" cy="0"/>
+        </a:xfrm>
+      </p:grpSpPr>
+      <p:sp>
+        <p:nvSpPr>
+          <p:cNvPr id="2" name="Title 1">
+            <a:extLst>
+              <a:ext uri="{FF2B5EF4-FFF2-40B4-BE49-F238E27FC236}">
+                <a16:creationId xmlns:a16="http://schemas.microsoft.com/office/drawing/2014/main" id="{5AAD0D87-F2B0-8B2D-EF2E-46095805DFAF}"/>
+              </a:ext>
+            </a:extLst>
+          </p:cNvPr>
+          <p:cNvSpPr>
+            <a:spLocks noGrp="1"/>
+          </p:cNvSpPr>
+          <p:nvPr>
+            <p:ph type="title"/>
+          </p:nvPr>
+        </p:nvSpPr>
+        <p:spPr>
+          <a:xfrm>
+            <a:off x="838200" y="365126"/>
+            <a:ext cx="10515600" cy="840528"/>
+          </a:xfrm>
+        </p:spPr>
+        <p:txBody>
+          <a:bodyPr/>
+          <a:lstStyle/>
+          <a:p>
+            <a:r>
+              <a:rPr lang="en-US" dirty="0"/>
+              <a:t>Azure deployment Architecture</a:t>
+            </a:r>
+          </a:p>
+        </p:txBody>
+      </p:sp>
+      <p:sp>
+        <p:nvSpPr>
+          <p:cNvPr id="3" name="Content Placeholder 2">
+            <a:extLst>
+              <a:ext uri="{FF2B5EF4-FFF2-40B4-BE49-F238E27FC236}">
+                <a16:creationId xmlns:a16="http://schemas.microsoft.com/office/drawing/2014/main" id="{B57A65A2-2228-D79B-C01D-3264AAB9155D}"/>
+              </a:ext>
+            </a:extLst>
+          </p:cNvPr>
+          <p:cNvSpPr>
+            <a:spLocks noGrp="1"/>
+          </p:cNvSpPr>
+          <p:nvPr>
+            <p:ph idx="1"/>
+          </p:nvPr>
+        </p:nvSpPr>
+        <p:spPr>
+          <a:xfrm>
+            <a:off x="458894" y="1541145"/>
+            <a:ext cx="3787987" cy="4351338"/>
+          </a:xfrm>
+        </p:spPr>
+        <p:txBody>
+          <a:bodyPr>
+            <a:normAutofit fontScale="32500" lnSpcReduction="20000"/>
+          </a:bodyPr>
+          <a:lstStyle/>
+          <a:p>
+            <a:r>
+              <a:rPr lang="en-US"/>
+              <a:t>Subscription: ChatHealthy</a:t>
+            </a:r>
+          </a:p>
+          <a:p>
+            <a:r>
+              <a:rPr lang="en-US"/>
+              <a:t>└── Resource Group: ChatHealthyDataPipelines</a:t>
+            </a:r>
+          </a:p>
+          <a:p>
+            <a:r>
+              <a:rPr lang="en-US"/>
+              <a:t>    ├── Tag: environment → dev | qa | prod</a:t>
+            </a:r>
+          </a:p>
+          <a:p>
+            <a:r>
+              <a:rPr lang="en-US"/>
+              <a:t>    ├── Tag: version     → 1.0.0</a:t>
+            </a:r>
+          </a:p>
+          <a:p>
+            <a:r>
+              <a:rPr lang="en-US"/>
+              <a:t>    │</a:t>
+            </a:r>
+          </a:p>
+          <a:p>
+            <a:r>
+              <a:rPr lang="en-US"/>
+              <a:t>    ├── Namespace: PipelineInfrastructure [SHARED]</a:t>
+            </a:r>
+          </a:p>
+          <a:p>
+            <a:r>
+              <a:rPr lang="en-US"/>
+              <a:t>    │   ├── Storage Account [SHARED]</a:t>
+            </a:r>
+          </a:p>
+          <a:p>
+            <a:r>
+              <a:rPr lang="en-US"/>
+              <a:t>    │   │   └── Blob Container</a:t>
+            </a:r>
+          </a:p>
+          <a:p>
+            <a:r>
+              <a:rPr lang="en-US"/>
+              <a:t>    │   │       └── Tag: environment → dev</a:t>
+            </a:r>
+          </a:p>
+          <a:p>
+            <a:r>
+              <a:rPr lang="en-US"/>
+              <a:t>    │   ├── Virtual Network / Subnet [SHARED]</a:t>
+            </a:r>
+          </a:p>
+          <a:p>
+            <a:r>
+              <a:rPr lang="en-US"/>
+              <a:t>    │   └── Key Vault [SHARED]</a:t>
+            </a:r>
+          </a:p>
+          <a:p>
+            <a:r>
+              <a:rPr lang="en-US"/>
+              <a:t>    │</a:t>
+            </a:r>
+          </a:p>
+          <a:p>
+            <a:r>
+              <a:rPr lang="en-US"/>
+              <a:t>    └── Namespace: ProviderDataPipelineApp</a:t>
+            </a:r>
+          </a:p>
+          <a:p>
+            <a:r>
+              <a:rPr lang="en-US"/>
+              <a:t>        ├── Function App: FetchAndDistributeProviderData</a:t>
+            </a:r>
+          </a:p>
+          <a:p>
+            <a:r>
+              <a:rPr lang="en-US"/>
+              <a:t>        │   └── Tag: environment → dev</a:t>
+            </a:r>
+          </a:p>
+          <a:p>
+            <a:r>
+              <a:rPr lang="en-US"/>
+              <a:t>        ├── Function App: NPDBDataToMongo</a:t>
+            </a:r>
+          </a:p>
+          <a:p>
+            <a:r>
+              <a:rPr lang="en-US"/>
+              <a:t>        │   └── Tag: environment → dev</a:t>
+            </a:r>
+          </a:p>
+          <a:p>
+            <a:r>
+              <a:rPr lang="en-US"/>
+              <a:t>        └── Storage → ref: PipelineInfrastructure</a:t>
+            </a:r>
+            <a:endParaRPr lang="en-US" dirty="0"/>
+          </a:p>
+        </p:txBody>
+      </p:sp>
+      <p:sp>
+        <p:nvSpPr>
+          <p:cNvPr id="4" name="TextBox 3">
+            <a:extLst>
+              <a:ext uri="{FF2B5EF4-FFF2-40B4-BE49-F238E27FC236}">
+                <a16:creationId xmlns:a16="http://schemas.microsoft.com/office/drawing/2014/main" id="{D7F92A63-5EF3-52A3-0F23-0077A9ABC82E}"/>
+              </a:ext>
+            </a:extLst>
+          </p:cNvPr>
+          <p:cNvSpPr txBox="1"/>
+          <p:nvPr/>
+        </p:nvSpPr>
+        <p:spPr>
+          <a:xfrm>
+            <a:off x="3578012" y="1541145"/>
+            <a:ext cx="7775788" cy="4893647"/>
+          </a:xfrm>
+          <a:prstGeom prst="rect">
+            <a:avLst/>
+          </a:prstGeom>
+          <a:noFill/>
+        </p:spPr>
+        <p:txBody>
+          <a:bodyPr wrap="square" rtlCol="0">
+            <a:spAutoFit/>
+          </a:bodyPr>
+          <a:lstStyle/>
+          <a:p>
+            <a:pPr marL="285750" indent="-285750">
+              <a:buFont typeface="Arial" panose="020B0604020202020204" pitchFamily="34" charset="0"/>
+              <a:buChar char="•"/>
+            </a:pPr>
+            <a:r>
+              <a:rPr lang="en-US" sz="2400" dirty="0">
+                <a:solidFill>
+                  <a:schemeClr val="tx1">
+                    <a:lumMod val="65000"/>
+                    <a:lumOff val="35000"/>
+                  </a:schemeClr>
+                </a:solidFill>
+              </a:rPr>
+              <a:t>The use of deployment facts in a predictable matter allow for a business to respond to changes to its operating model. </a:t>
+            </a:r>
+          </a:p>
+          <a:p>
+            <a:pPr marL="742950" lvl="1" indent="-285750">
+              <a:buFont typeface="Arial" panose="020B0604020202020204" pitchFamily="34" charset="0"/>
+              <a:buChar char="•"/>
+            </a:pPr>
+            <a:r>
+              <a:rPr lang="en-US" sz="2400" dirty="0">
+                <a:solidFill>
+                  <a:schemeClr val="tx1">
+                    <a:lumMod val="65000"/>
+                    <a:lumOff val="35000"/>
+                  </a:schemeClr>
+                </a:solidFill>
+              </a:rPr>
+              <a:t>Resource groups can cross all boundaries but should be </a:t>
+            </a:r>
+            <a:r>
+              <a:rPr lang="en-US" sz="2400" dirty="0" err="1">
+                <a:solidFill>
+                  <a:schemeClr val="tx1">
+                    <a:lumMod val="65000"/>
+                    <a:lumOff val="35000"/>
+                  </a:schemeClr>
+                </a:solidFill>
+              </a:rPr>
+              <a:t>maped</a:t>
+            </a:r>
+            <a:r>
+              <a:rPr lang="en-US" sz="2400" dirty="0">
+                <a:solidFill>
+                  <a:schemeClr val="tx1">
+                    <a:lumMod val="65000"/>
+                    <a:lumOff val="35000"/>
+                  </a:schemeClr>
+                </a:solidFill>
+              </a:rPr>
+              <a:t> to an accounting and HR model. </a:t>
+            </a:r>
+          </a:p>
+          <a:p>
+            <a:pPr marL="742950" lvl="1" indent="-285750">
+              <a:buFont typeface="Arial" panose="020B0604020202020204" pitchFamily="34" charset="0"/>
+              <a:buChar char="•"/>
+            </a:pPr>
+            <a:r>
+              <a:rPr lang="en-US" sz="2400" dirty="0">
+                <a:solidFill>
+                  <a:schemeClr val="tx1">
+                    <a:lumMod val="65000"/>
+                    <a:lumOff val="35000"/>
+                  </a:schemeClr>
+                </a:solidFill>
+              </a:rPr>
+              <a:t>Other resource groups to be created are and two are planed, </a:t>
+            </a:r>
+          </a:p>
+          <a:p>
+            <a:pPr marL="1200150" lvl="2" indent="-285750">
+              <a:buFont typeface="Arial" panose="020B0604020202020204" pitchFamily="34" charset="0"/>
+              <a:buChar char="•"/>
+            </a:pPr>
+            <a:r>
+              <a:rPr lang="en-US" sz="2400" dirty="0">
+                <a:solidFill>
+                  <a:schemeClr val="tx1">
+                    <a:lumMod val="65000"/>
+                    <a:lumOff val="35000"/>
+                  </a:schemeClr>
+                </a:solidFill>
+              </a:rPr>
+              <a:t>Chat </a:t>
+            </a:r>
+            <a:r>
+              <a:rPr lang="en-US" sz="2400" dirty="0" err="1">
+                <a:solidFill>
+                  <a:schemeClr val="tx1">
+                    <a:lumMod val="65000"/>
+                    <a:lumOff val="35000"/>
+                  </a:schemeClr>
+                </a:solidFill>
+              </a:rPr>
+              <a:t>HealthyTest</a:t>
+            </a:r>
+            <a:r>
+              <a:rPr lang="en-US" sz="2400" dirty="0">
+                <a:solidFill>
+                  <a:schemeClr val="tx1">
+                    <a:lumMod val="65000"/>
+                    <a:lumOff val="35000"/>
+                  </a:schemeClr>
+                </a:solidFill>
+              </a:rPr>
+              <a:t>,  This is where the accuracy  chat Healthy's responses are tested against Boolean based criteria. And design decisions are revisited. </a:t>
+            </a:r>
+          </a:p>
+          <a:p>
+            <a:pPr marL="1200150" lvl="2" indent="-285750">
+              <a:buFont typeface="Arial" panose="020B0604020202020204" pitchFamily="34" charset="0"/>
+              <a:buChar char="•"/>
+            </a:pPr>
+            <a:r>
+              <a:rPr lang="en-US" sz="2400" dirty="0">
+                <a:solidFill>
+                  <a:schemeClr val="tx1">
+                    <a:lumMod val="65000"/>
+                    <a:lumOff val="35000"/>
+                  </a:schemeClr>
+                </a:solidFill>
+              </a:rPr>
+              <a:t>Find Care Run Time application</a:t>
+            </a:r>
+          </a:p>
+          <a:p>
+            <a:pPr marL="742950" lvl="1" indent="-285750">
+              <a:buFont typeface="Arial" panose="020B0604020202020204" pitchFamily="34" charset="0"/>
+              <a:buChar char="•"/>
+            </a:pPr>
+            <a:r>
+              <a:rPr lang="en-US" sz="2400" dirty="0">
+                <a:solidFill>
+                  <a:schemeClr val="tx1">
+                    <a:lumMod val="65000"/>
+                    <a:lumOff val="35000"/>
+                  </a:schemeClr>
+                </a:solidFill>
+              </a:rPr>
+              <a:t>There is only 1 azure subscription</a:t>
+            </a:r>
+            <a:r>
+              <a:rPr lang="en-US" dirty="0">
+                <a:solidFill>
+                  <a:schemeClr val="tx1">
+                    <a:lumMod val="65000"/>
+                    <a:lumOff val="35000"/>
+                  </a:schemeClr>
+                </a:solidFill>
+              </a:rPr>
+              <a:t>. </a:t>
+            </a:r>
+          </a:p>
+        </p:txBody>
+      </p:sp>
+    </p:spTree>
+    <p:extLst>
+      <p:ext uri="{BB962C8B-B14F-4D97-AF65-F5344CB8AC3E}">
+        <p14:creationId xmlns:p14="http://schemas.microsoft.com/office/powerpoint/2010/main" val="1988505791"/>
+      </p:ext>
+    </p:extLst>
+  </p:cSld>
+  <p:clrMapOvr>
+    <a:masterClrMapping/>
+  </p:clrMapOvr>
+</p:sld>
+</file>
+
 <file path=ppt/slides/slide2.xml><?xml version="1.0" encoding="utf-8"?>
 <p:sld xmlns:a="http://schemas.openxmlformats.org/drawingml/2006/main" xmlns:r="http://schemas.openxmlformats.org/officeDocument/2006/relationships" xmlns:p="http://schemas.openxmlformats.org/presentationml/2006/main">
   <p:cSld>
@@ -3440,7 +3830,7 @@
           <p:cNvPr id="2" name="Title 1">
             <a:extLst>
               <a:ext uri="{FF2B5EF4-FFF2-40B4-BE49-F238E27FC236}">
-                <a16:creationId xmlns:a16="http://schemas.microsoft.com/office/drawing/2014/main" id="{E5887721-0EA8-D9F6-8F33-FCE1615E926D}"/>
+                <a16:creationId xmlns:a16="http://schemas.microsoft.com/office/drawing/2014/main" id="{71B4603E-5B2F-898B-0A63-6AAD9C4CF6C2}"/>
               </a:ext>
             </a:extLst>
           </p:cNvPr>
@@ -3451,29 +3841,24 @@
             <p:ph type="title"/>
           </p:nvPr>
         </p:nvSpPr>
-        <p:spPr>
-          <a:xfrm>
-            <a:off x="149087" y="0"/>
-            <a:ext cx="10515600" cy="1325563"/>
-          </a:xfrm>
-        </p:spPr>
+        <p:spPr/>
         <p:txBody>
           <a:bodyPr/>
           <a:lstStyle/>
           <a:p>
             <a:r>
               <a:rPr lang="en-US" dirty="0"/>
-              <a:t>Project goals</a:t>
-            </a:r>
-          </a:p>
-        </p:txBody>
-      </p:sp>
-      <p:sp>
-        <p:nvSpPr>
-          <p:cNvPr id="3" name="Content Placeholder 2">
-            <a:extLst>
-              <a:ext uri="{FF2B5EF4-FFF2-40B4-BE49-F238E27FC236}">
-                <a16:creationId xmlns:a16="http://schemas.microsoft.com/office/drawing/2014/main" id="{ED01B8D9-DA65-FC4E-DF50-72FE67B3F2B5}"/>
+              <a:t>Overview</a:t>
+            </a:r>
+          </a:p>
+        </p:txBody>
+      </p:sp>
+      <p:sp>
+        <p:nvSpPr>
+          <p:cNvPr id="4" name="Content Placeholder 3">
+            <a:extLst>
+              <a:ext uri="{FF2B5EF4-FFF2-40B4-BE49-F238E27FC236}">
+                <a16:creationId xmlns:a16="http://schemas.microsoft.com/office/drawing/2014/main" id="{80AADAC0-7C52-1AA2-ED05-3227D8D3894F}"/>
               </a:ext>
             </a:extLst>
           </p:cNvPr>
@@ -3484,62 +3869,26 @@
             <p:ph idx="1"/>
           </p:nvPr>
         </p:nvSpPr>
-        <p:spPr>
-          <a:xfrm>
-            <a:off x="838200" y="1500369"/>
-            <a:ext cx="10515600" cy="4351338"/>
-          </a:xfrm>
-        </p:spPr>
+        <p:spPr/>
         <p:txBody>
           <a:bodyPr/>
           <a:lstStyle/>
           <a:p>
             <a:r>
               <a:rPr lang="en-US" dirty="0"/>
-              <a:t>Create website that:</a:t>
-            </a:r>
-          </a:p>
-          <a:p>
-            <a:pPr lvl="1"/>
+              <a:t>The Find care application demonstrates all the core competencies to solve AI problems using a variety of AI techniques and tools. </a:t>
+            </a:r>
+          </a:p>
+          <a:p>
             <a:r>
               <a:rPr lang="en-US" dirty="0"/>
-              <a:t> Allows via chat interface a user to find care.</a:t>
-            </a:r>
-          </a:p>
-          <a:p>
-            <a:pPr lvl="1"/>
+              <a:t>In addition, it is the MVP for an AI application that can help consumers and healthcare professionals to find care for particular types of facilities and problems. </a:t>
+            </a:r>
+          </a:p>
+          <a:p>
             <a:r>
               <a:rPr lang="en-US" dirty="0"/>
-              <a:t>Keep data fresh and accurate (phase 1 operational)</a:t>
-            </a:r>
-          </a:p>
-          <a:p>
-            <a:pPr lvl="1"/>
-            <a:r>
-              <a:rPr lang="en-US" dirty="0"/>
-              <a:t>Allow users to ask general questions about the American health care system.</a:t>
-            </a:r>
-          </a:p>
-          <a:p>
-            <a:pPr lvl="1"/>
-            <a:r>
-              <a:rPr lang="en-US" dirty="0"/>
-              <a:t>Do not under any circumstances give medical advise beyond what types of care to seek	 based on user input.</a:t>
-            </a:r>
-          </a:p>
-          <a:p>
-            <a:pPr lvl="1"/>
-            <a:r>
-              <a:rPr lang="en-US" dirty="0"/>
-              <a:t>While ensuring user privacy, keep a log of user </a:t>
-            </a:r>
-            <a:r>
-              <a:rPr lang="en-US" dirty="0" err="1"/>
-              <a:t>activiteis</a:t>
-            </a:r>
-            <a:r>
-              <a:rPr lang="en-US" dirty="0"/>
-              <a:t> based on cookies and or registration. (Ensure that the HIPAA laws around ‘research data are preserved and declare in privacy statement that all user data is anonymized as per HIPAA standards. </a:t>
+              <a:t>It also offers hospitals and health insurance companies a starter kit to manage their own networks of providers. </a:t>
             </a:r>
           </a:p>
         </p:txBody>
@@ -3547,7 +3896,7 @@
     </p:spTree>
     <p:extLst>
       <p:ext uri="{BB962C8B-B14F-4D97-AF65-F5344CB8AC3E}">
-        <p14:creationId xmlns:p14="http://schemas.microsoft.com/office/powerpoint/2010/main" val="2044576727"/>
+        <p14:creationId xmlns:p14="http://schemas.microsoft.com/office/powerpoint/2010/main" val="2946898916"/>
       </p:ext>
     </p:extLst>
   </p:cSld>
@@ -3579,7 +3928,7 @@
           <p:cNvPr id="2" name="Title 1">
             <a:extLst>
               <a:ext uri="{FF2B5EF4-FFF2-40B4-BE49-F238E27FC236}">
-                <a16:creationId xmlns:a16="http://schemas.microsoft.com/office/drawing/2014/main" id="{E7EF3A8B-45CB-F213-3E39-9E312BA74D76}"/>
+                <a16:creationId xmlns:a16="http://schemas.microsoft.com/office/drawing/2014/main" id="{E5887721-0EA8-D9F6-8F33-FCE1615E926D}"/>
               </a:ext>
             </a:extLst>
           </p:cNvPr>
@@ -3592,7 +3941,138 @@
         </p:nvSpPr>
         <p:spPr>
           <a:xfrm>
-            <a:off x="106680" y="0"/>
+            <a:off x="149087" y="0"/>
+            <a:ext cx="10515600" cy="1325563"/>
+          </a:xfrm>
+        </p:spPr>
+        <p:txBody>
+          <a:bodyPr/>
+          <a:lstStyle/>
+          <a:p>
+            <a:r>
+              <a:rPr lang="en-US" dirty="0"/>
+              <a:t>Project goals</a:t>
+            </a:r>
+          </a:p>
+        </p:txBody>
+      </p:sp>
+      <p:sp>
+        <p:nvSpPr>
+          <p:cNvPr id="3" name="Content Placeholder 2">
+            <a:extLst>
+              <a:ext uri="{FF2B5EF4-FFF2-40B4-BE49-F238E27FC236}">
+                <a16:creationId xmlns:a16="http://schemas.microsoft.com/office/drawing/2014/main" id="{ED01B8D9-DA65-FC4E-DF50-72FE67B3F2B5}"/>
+              </a:ext>
+            </a:extLst>
+          </p:cNvPr>
+          <p:cNvSpPr>
+            <a:spLocks noGrp="1"/>
+          </p:cNvSpPr>
+          <p:nvPr>
+            <p:ph idx="1"/>
+          </p:nvPr>
+        </p:nvSpPr>
+        <p:spPr>
+          <a:xfrm>
+            <a:off x="838200" y="1500369"/>
+            <a:ext cx="10515600" cy="4351338"/>
+          </a:xfrm>
+        </p:spPr>
+        <p:txBody>
+          <a:bodyPr/>
+          <a:lstStyle/>
+          <a:p>
+            <a:r>
+              <a:rPr lang="en-US" dirty="0"/>
+              <a:t>Create website that:</a:t>
+            </a:r>
+          </a:p>
+          <a:p>
+            <a:pPr lvl="1"/>
+            <a:r>
+              <a:rPr lang="en-US" dirty="0"/>
+              <a:t> Allows via chat interface a user to find care.</a:t>
+            </a:r>
+          </a:p>
+          <a:p>
+            <a:pPr lvl="1"/>
+            <a:r>
+              <a:rPr lang="en-US" dirty="0"/>
+              <a:t>Keep data fresh and accurate (phase 1 operational)</a:t>
+            </a:r>
+          </a:p>
+          <a:p>
+            <a:pPr lvl="1"/>
+            <a:r>
+              <a:rPr lang="en-US" dirty="0"/>
+              <a:t>Allow users to ask general questions about the American health care system.</a:t>
+            </a:r>
+          </a:p>
+          <a:p>
+            <a:pPr lvl="1"/>
+            <a:r>
+              <a:rPr lang="en-US" dirty="0"/>
+              <a:t>Do not under any circumstances give medical advise beyond what types of care to seek	 based on user input.</a:t>
+            </a:r>
+          </a:p>
+          <a:p>
+            <a:pPr lvl="1"/>
+            <a:r>
+              <a:rPr lang="en-US" dirty="0"/>
+              <a:t>While ensuring user privacy, keep a log of user activities based on cookies and or registration. (Ensure that the HIPAA laws around ‘research data are preserved and declare in privacy statement that all user data is anonymized as per HIPAA standards. </a:t>
+            </a:r>
+          </a:p>
+        </p:txBody>
+      </p:sp>
+    </p:spTree>
+    <p:extLst>
+      <p:ext uri="{BB962C8B-B14F-4D97-AF65-F5344CB8AC3E}">
+        <p14:creationId xmlns:p14="http://schemas.microsoft.com/office/powerpoint/2010/main" val="2044576727"/>
+      </p:ext>
+    </p:extLst>
+  </p:cSld>
+  <p:clrMapOvr>
+    <a:masterClrMapping/>
+  </p:clrMapOvr>
+</p:sld>
+</file>
+
+<file path=ppt/slides/slide4.xml><?xml version="1.0" encoding="utf-8"?>
+<p:sld xmlns:a="http://schemas.openxmlformats.org/drawingml/2006/main" xmlns:r="http://schemas.openxmlformats.org/officeDocument/2006/relationships" xmlns:p="http://schemas.openxmlformats.org/presentationml/2006/main">
+  <p:cSld>
+    <p:spTree>
+      <p:nvGrpSpPr>
+        <p:cNvPr id="1" name=""/>
+        <p:cNvGrpSpPr/>
+        <p:nvPr/>
+      </p:nvGrpSpPr>
+      <p:grpSpPr>
+        <a:xfrm>
+          <a:off x="0" y="0"/>
+          <a:ext cx="0" cy="0"/>
+          <a:chOff x="0" y="0"/>
+          <a:chExt cx="0" cy="0"/>
+        </a:xfrm>
+      </p:grpSpPr>
+      <p:sp>
+        <p:nvSpPr>
+          <p:cNvPr id="2" name="Title 1">
+            <a:extLst>
+              <a:ext uri="{FF2B5EF4-FFF2-40B4-BE49-F238E27FC236}">
+                <a16:creationId xmlns:a16="http://schemas.microsoft.com/office/drawing/2014/main" id="{E7EF3A8B-45CB-F213-3E39-9E312BA74D76}"/>
+              </a:ext>
+            </a:extLst>
+          </p:cNvPr>
+          <p:cNvSpPr>
+            <a:spLocks noGrp="1"/>
+          </p:cNvSpPr>
+          <p:nvPr>
+            <p:ph type="title"/>
+          </p:nvPr>
+        </p:nvSpPr>
+        <p:spPr>
+          <a:xfrm>
+            <a:off x="0" y="-66708"/>
             <a:ext cx="10515600" cy="671195"/>
           </a:xfrm>
         </p:spPr>
@@ -3624,7 +4104,7 @@
         <p:spPr>
           <a:xfrm>
             <a:off x="618282" y="1109554"/>
-            <a:ext cx="4903894" cy="5350933"/>
+            <a:ext cx="3419807" cy="5143959"/>
           </a:xfrm>
           <a:prstGeom prst="rect">
             <a:avLst/>
@@ -3676,8 +4156,8 @@
         </p:nvSpPr>
         <p:spPr>
           <a:xfrm>
-            <a:off x="724747" y="1706879"/>
-            <a:ext cx="2451946" cy="1205654"/>
+            <a:off x="724746" y="1706879"/>
+            <a:ext cx="3215151" cy="4172284"/>
           </a:xfrm>
           <a:prstGeom prst="rect">
             <a:avLst/>
@@ -3731,7 +4211,7 @@
                   <a:schemeClr val="tx1"/>
                 </a:solidFill>
               </a:rPr>
-              <a:t>-AI</a:t>
+              <a:t>-AI US EAST2</a:t>
             </a:r>
           </a:p>
         </p:txBody>
@@ -3750,8 +4230,8 @@
         </p:nvSpPr>
         <p:spPr>
           <a:xfrm>
-            <a:off x="6263218" y="1194448"/>
-            <a:ext cx="3193765" cy="2831367"/>
+            <a:off x="4301977" y="1109554"/>
+            <a:ext cx="3288792" cy="2831367"/>
           </a:xfrm>
           <a:prstGeom prst="rect">
             <a:avLst/>
@@ -3787,7 +4267,7 @@
             <a:pPr algn="ctr"/>
             <a:r>
               <a:rPr lang="en-US" dirty="0"/>
-              <a:t>chatHealthy.ai</a:t>
+              <a:t>wwww.chatHealthy.ai</a:t>
             </a:r>
           </a:p>
           <a:p>
@@ -3810,8 +4290,8 @@
         </p:nvSpPr>
         <p:spPr>
           <a:xfrm>
-            <a:off x="6339430" y="4394029"/>
-            <a:ext cx="3332343" cy="2066458"/>
+            <a:off x="4258426" y="4136278"/>
+            <a:ext cx="3332343" cy="2117235"/>
           </a:xfrm>
           <a:prstGeom prst="rect">
             <a:avLst/>
@@ -3839,7 +4319,7 @@
           <a:p>
             <a:pPr algn="ctr"/>
             <a:r>
-              <a:rPr lang="en-US" sz="2800"/>
+              <a:rPr lang="en-US" sz="2800" dirty="0"/>
               <a:t>Mongo</a:t>
             </a:r>
             <a:endParaRPr lang="en-US" dirty="0"/>
@@ -3847,6 +4327,867 @@
           <a:p>
             <a:pPr algn="ctr"/>
             <a:endParaRPr lang="en-US" dirty="0"/>
+          </a:p>
+        </p:txBody>
+      </p:sp>
+      <p:sp>
+        <p:nvSpPr>
+          <p:cNvPr id="5" name="Rectangle 4">
+            <a:extLst>
+              <a:ext uri="{FF2B5EF4-FFF2-40B4-BE49-F238E27FC236}">
+                <a16:creationId xmlns:a16="http://schemas.microsoft.com/office/drawing/2014/main" id="{4FB839EA-6292-36AA-C643-1371E9934750}"/>
+              </a:ext>
+            </a:extLst>
+          </p:cNvPr>
+          <p:cNvSpPr/>
+          <p:nvPr/>
+        </p:nvSpPr>
+        <p:spPr>
+          <a:xfrm>
+            <a:off x="7811106" y="1109554"/>
+            <a:ext cx="4033136" cy="1885259"/>
+          </a:xfrm>
+          <a:prstGeom prst="rect">
+            <a:avLst/>
+          </a:prstGeom>
+        </p:spPr>
+        <p:style>
+          <a:lnRef idx="2">
+            <a:schemeClr val="accent1">
+              <a:shade val="15000"/>
+            </a:schemeClr>
+          </a:lnRef>
+          <a:fillRef idx="1">
+            <a:schemeClr val="accent1"/>
+          </a:fillRef>
+          <a:effectRef idx="0">
+            <a:schemeClr val="accent1"/>
+          </a:effectRef>
+          <a:fontRef idx="minor">
+            <a:schemeClr val="lt1"/>
+          </a:fontRef>
+        </p:style>
+        <p:txBody>
+          <a:bodyPr rtlCol="0" anchor="t"/>
+          <a:lstStyle/>
+          <a:p>
+            <a:pPr algn="ctr"/>
+            <a:r>
+              <a:rPr lang="en-US" sz="2800" dirty="0"/>
+              <a:t>Hugging Face</a:t>
+            </a:r>
+          </a:p>
+          <a:p>
+            <a:pPr algn="ctr"/>
+            <a:r>
+              <a:rPr lang="en-US" dirty="0"/>
+              <a:t>chatHealthy.ai</a:t>
+            </a:r>
+          </a:p>
+          <a:p>
+            <a:pPr algn="ctr"/>
+            <a:endParaRPr lang="en-US" dirty="0"/>
+          </a:p>
+        </p:txBody>
+      </p:sp>
+      <p:sp>
+        <p:nvSpPr>
+          <p:cNvPr id="7" name="Rectangle 6">
+            <a:extLst>
+              <a:ext uri="{FF2B5EF4-FFF2-40B4-BE49-F238E27FC236}">
+                <a16:creationId xmlns:a16="http://schemas.microsoft.com/office/drawing/2014/main" id="{B52B02C8-BFD3-2AEE-43C7-8E5E25B7EC4F}"/>
+              </a:ext>
+            </a:extLst>
+          </p:cNvPr>
+          <p:cNvSpPr/>
+          <p:nvPr/>
+        </p:nvSpPr>
+        <p:spPr>
+          <a:xfrm>
+            <a:off x="7811106" y="3185058"/>
+            <a:ext cx="4112322" cy="3068455"/>
+          </a:xfrm>
+          <a:prstGeom prst="rect">
+            <a:avLst/>
+          </a:prstGeom>
+        </p:spPr>
+        <p:style>
+          <a:lnRef idx="2">
+            <a:schemeClr val="accent1">
+              <a:shade val="15000"/>
+            </a:schemeClr>
+          </a:lnRef>
+          <a:fillRef idx="1">
+            <a:schemeClr val="accent1"/>
+          </a:fillRef>
+          <a:effectRef idx="0">
+            <a:schemeClr val="accent1"/>
+          </a:effectRef>
+          <a:fontRef idx="minor">
+            <a:schemeClr val="lt1"/>
+          </a:fontRef>
+        </p:style>
+        <p:txBody>
+          <a:bodyPr rtlCol="0" anchor="t"/>
+          <a:lstStyle/>
+          <a:p>
+            <a:pPr algn="ctr"/>
+            <a:r>
+              <a:rPr lang="en-US" sz="2800" dirty="0"/>
+              <a:t>Dev Ops</a:t>
+            </a:r>
+          </a:p>
+          <a:p>
+            <a:pPr algn="ctr"/>
+            <a:endParaRPr lang="en-US" dirty="0"/>
+          </a:p>
+        </p:txBody>
+      </p:sp>
+      <p:sp>
+        <p:nvSpPr>
+          <p:cNvPr id="9" name="Rectangle 8">
+            <a:extLst>
+              <a:ext uri="{FF2B5EF4-FFF2-40B4-BE49-F238E27FC236}">
+                <a16:creationId xmlns:a16="http://schemas.microsoft.com/office/drawing/2014/main" id="{B34CF8D7-9615-D6E5-BC07-A165752728BC}"/>
+              </a:ext>
+            </a:extLst>
+          </p:cNvPr>
+          <p:cNvSpPr/>
+          <p:nvPr/>
+        </p:nvSpPr>
+        <p:spPr>
+          <a:xfrm>
+            <a:off x="945083" y="2043057"/>
+            <a:ext cx="2872077" cy="2093221"/>
+          </a:xfrm>
+          <a:prstGeom prst="rect">
+            <a:avLst/>
+          </a:prstGeom>
+          <a:solidFill>
+            <a:schemeClr val="accent6">
+              <a:lumMod val="20000"/>
+              <a:lumOff val="80000"/>
+            </a:schemeClr>
+          </a:solidFill>
+        </p:spPr>
+        <p:style>
+          <a:lnRef idx="2">
+            <a:schemeClr val="accent1">
+              <a:shade val="15000"/>
+            </a:schemeClr>
+          </a:lnRef>
+          <a:fillRef idx="1">
+            <a:schemeClr val="accent1"/>
+          </a:fillRef>
+          <a:effectRef idx="0">
+            <a:schemeClr val="accent1"/>
+          </a:effectRef>
+          <a:fontRef idx="minor">
+            <a:schemeClr val="lt1"/>
+          </a:fontRef>
+        </p:style>
+        <p:txBody>
+          <a:bodyPr rtlCol="0" anchor="t"/>
+          <a:lstStyle/>
+          <a:p>
+            <a:pPr marL="285750" indent="-285750">
+              <a:buFont typeface="Arial" panose="020B0604020202020204" pitchFamily="34" charset="0"/>
+              <a:buChar char="•"/>
+            </a:pPr>
+            <a:r>
+              <a:rPr lang="en-US" sz="1200" dirty="0">
+                <a:solidFill>
+                  <a:schemeClr val="tx1"/>
+                </a:solidFill>
+              </a:rPr>
+              <a:t>Function App- Pay Per use</a:t>
+            </a:r>
+          </a:p>
+          <a:p>
+            <a:pPr marL="742950" lvl="1" indent="-285750">
+              <a:buFont typeface="Arial" panose="020B0604020202020204" pitchFamily="34" charset="0"/>
+              <a:buChar char="•"/>
+            </a:pPr>
+            <a:r>
+              <a:rPr lang="en-US" sz="1200" dirty="0">
+                <a:solidFill>
+                  <a:schemeClr val="tx1"/>
+                </a:solidFill>
+              </a:rPr>
+              <a:t>DevPipelineManagment Services</a:t>
+            </a:r>
+          </a:p>
+          <a:p>
+            <a:pPr marL="742950" lvl="1" indent="-285750">
+              <a:buFont typeface="Arial" panose="020B0604020202020204" pitchFamily="34" charset="0"/>
+              <a:buChar char="•"/>
+            </a:pPr>
+            <a:r>
+              <a:rPr lang="en-US" sz="1200" dirty="0">
+                <a:solidFill>
+                  <a:schemeClr val="tx1"/>
+                </a:solidFill>
+              </a:rPr>
+              <a:t>Python 12.10.2</a:t>
+            </a:r>
+          </a:p>
+          <a:p>
+            <a:pPr marL="285750" indent="-285750">
+              <a:buFont typeface="Arial" panose="020B0604020202020204" pitchFamily="34" charset="0"/>
+              <a:buChar char="•"/>
+            </a:pPr>
+            <a:r>
+              <a:rPr lang="en-US" sz="1200" dirty="0">
+                <a:solidFill>
+                  <a:schemeClr val="tx1"/>
+                </a:solidFill>
+              </a:rPr>
+              <a:t>Core coded in Python library: ChatHealthyLib.pipelines</a:t>
+            </a:r>
+          </a:p>
+          <a:p>
+            <a:pPr marL="285750" indent="-285750">
+              <a:buFont typeface="Arial" panose="020B0604020202020204" pitchFamily="34" charset="0"/>
+              <a:buChar char="•"/>
+            </a:pPr>
+            <a:endParaRPr lang="en-US" sz="1200" dirty="0">
+              <a:solidFill>
+                <a:schemeClr val="tx1"/>
+              </a:solidFill>
+            </a:endParaRPr>
+          </a:p>
+          <a:p>
+            <a:pPr marL="285750" indent="-285750">
+              <a:buFont typeface="Arial" panose="020B0604020202020204" pitchFamily="34" charset="0"/>
+              <a:buChar char="•"/>
+            </a:pPr>
+            <a:endParaRPr lang="en-US" sz="1400" dirty="0"/>
+          </a:p>
+        </p:txBody>
+      </p:sp>
+      <p:sp>
+        <p:nvSpPr>
+          <p:cNvPr id="10" name="Rectangle 9">
+            <a:extLst>
+              <a:ext uri="{FF2B5EF4-FFF2-40B4-BE49-F238E27FC236}">
+                <a16:creationId xmlns:a16="http://schemas.microsoft.com/office/drawing/2014/main" id="{93CADF12-0896-E739-AC56-E38C4B895E06}"/>
+              </a:ext>
+            </a:extLst>
+          </p:cNvPr>
+          <p:cNvSpPr/>
+          <p:nvPr/>
+        </p:nvSpPr>
+        <p:spPr>
+          <a:xfrm>
+            <a:off x="4580962" y="1990206"/>
+            <a:ext cx="2647727" cy="1317590"/>
+          </a:xfrm>
+          <a:prstGeom prst="rect">
+            <a:avLst/>
+          </a:prstGeom>
+          <a:solidFill>
+            <a:schemeClr val="accent6">
+              <a:lumMod val="20000"/>
+              <a:lumOff val="80000"/>
+            </a:schemeClr>
+          </a:solidFill>
+        </p:spPr>
+        <p:style>
+          <a:lnRef idx="2">
+            <a:schemeClr val="accent1">
+              <a:shade val="15000"/>
+            </a:schemeClr>
+          </a:lnRef>
+          <a:fillRef idx="1">
+            <a:schemeClr val="accent1"/>
+          </a:fillRef>
+          <a:effectRef idx="0">
+            <a:schemeClr val="accent1"/>
+          </a:effectRef>
+          <a:fontRef idx="minor">
+            <a:schemeClr val="lt1"/>
+          </a:fontRef>
+        </p:style>
+        <p:txBody>
+          <a:bodyPr rtlCol="0" anchor="t"/>
+          <a:lstStyle/>
+          <a:p>
+            <a:pPr marL="285750" indent="-285750">
+              <a:buFont typeface="Arial" panose="020B0604020202020204" pitchFamily="34" charset="0"/>
+              <a:buChar char="•"/>
+            </a:pPr>
+            <a:r>
+              <a:rPr lang="en-US" sz="1200" dirty="0">
+                <a:solidFill>
+                  <a:schemeClr val="tx1"/>
+                </a:solidFill>
+              </a:rPr>
+              <a:t>Host static Web Pages</a:t>
+            </a:r>
+          </a:p>
+          <a:p>
+            <a:pPr marL="285750" indent="-285750">
+              <a:buFont typeface="Arial" panose="020B0604020202020204" pitchFamily="34" charset="0"/>
+              <a:buChar char="•"/>
+            </a:pPr>
+            <a:r>
+              <a:rPr lang="en-US" sz="1200" dirty="0">
+                <a:solidFill>
+                  <a:schemeClr val="tx1"/>
+                </a:solidFill>
+              </a:rPr>
+              <a:t>DNS services</a:t>
+            </a:r>
+          </a:p>
+          <a:p>
+            <a:pPr marL="285750" indent="-285750">
+              <a:buFont typeface="Arial" panose="020B0604020202020204" pitchFamily="34" charset="0"/>
+              <a:buChar char="•"/>
+            </a:pPr>
+            <a:r>
+              <a:rPr lang="en-US" sz="1200" dirty="0">
+                <a:solidFill>
+                  <a:schemeClr val="tx1"/>
+                </a:solidFill>
+              </a:rPr>
+              <a:t>Page to embed </a:t>
+            </a:r>
+            <a:r>
+              <a:rPr lang="en-US" sz="1200" dirty="0" err="1">
+                <a:solidFill>
+                  <a:schemeClr val="tx1"/>
+                </a:solidFill>
+              </a:rPr>
+              <a:t>CoreChatUX</a:t>
+            </a:r>
+            <a:r>
+              <a:rPr lang="en-US" sz="1200" dirty="0">
+                <a:solidFill>
+                  <a:schemeClr val="tx1"/>
+                </a:solidFill>
+              </a:rPr>
+              <a:t> inside of </a:t>
+            </a:r>
+            <a:r>
+              <a:rPr lang="en-US" sz="1200" dirty="0" err="1">
+                <a:solidFill>
+                  <a:schemeClr val="tx1"/>
+                </a:solidFill>
+              </a:rPr>
+              <a:t>HTMLl</a:t>
+            </a:r>
+            <a:r>
+              <a:rPr lang="en-US" sz="1200" dirty="0">
+                <a:solidFill>
+                  <a:schemeClr val="tx1"/>
+                </a:solidFill>
+              </a:rPr>
+              <a:t> Page</a:t>
+            </a:r>
+          </a:p>
+        </p:txBody>
+      </p:sp>
+      <p:sp>
+        <p:nvSpPr>
+          <p:cNvPr id="11" name="Rectangle 10">
+            <a:extLst>
+              <a:ext uri="{FF2B5EF4-FFF2-40B4-BE49-F238E27FC236}">
+                <a16:creationId xmlns:a16="http://schemas.microsoft.com/office/drawing/2014/main" id="{3C160D1D-9642-343D-FF25-28E07B3C1D3F}"/>
+              </a:ext>
+            </a:extLst>
+          </p:cNvPr>
+          <p:cNvSpPr/>
+          <p:nvPr/>
+        </p:nvSpPr>
+        <p:spPr>
+          <a:xfrm>
+            <a:off x="8235211" y="1968499"/>
+            <a:ext cx="2135081" cy="716037"/>
+          </a:xfrm>
+          <a:prstGeom prst="rect">
+            <a:avLst/>
+          </a:prstGeom>
+          <a:solidFill>
+            <a:schemeClr val="accent6">
+              <a:lumMod val="20000"/>
+              <a:lumOff val="80000"/>
+            </a:schemeClr>
+          </a:solidFill>
+        </p:spPr>
+        <p:style>
+          <a:lnRef idx="2">
+            <a:schemeClr val="accent1">
+              <a:shade val="15000"/>
+            </a:schemeClr>
+          </a:lnRef>
+          <a:fillRef idx="1">
+            <a:schemeClr val="accent1"/>
+          </a:fillRef>
+          <a:effectRef idx="0">
+            <a:schemeClr val="accent1"/>
+          </a:effectRef>
+          <a:fontRef idx="minor">
+            <a:schemeClr val="lt1"/>
+          </a:fontRef>
+        </p:style>
+        <p:txBody>
+          <a:bodyPr rtlCol="0" anchor="t"/>
+          <a:lstStyle/>
+          <a:p>
+            <a:pPr marL="285750" indent="-285750">
+              <a:buFont typeface="Arial" panose="020B0604020202020204" pitchFamily="34" charset="0"/>
+              <a:buChar char="•"/>
+            </a:pPr>
+            <a:r>
+              <a:rPr lang="en-US" sz="1200" dirty="0">
+                <a:solidFill>
+                  <a:schemeClr val="tx1"/>
+                </a:solidFill>
+              </a:rPr>
+              <a:t>Core Chat UX </a:t>
+            </a:r>
+          </a:p>
+          <a:p>
+            <a:pPr marL="285750" indent="-285750">
+              <a:buFont typeface="Arial" panose="020B0604020202020204" pitchFamily="34" charset="0"/>
+              <a:buChar char="•"/>
+            </a:pPr>
+            <a:r>
+              <a:rPr lang="en-US" sz="1200" dirty="0">
+                <a:solidFill>
+                  <a:schemeClr val="tx1"/>
+                </a:solidFill>
+              </a:rPr>
+              <a:t>AI GPU </a:t>
+            </a:r>
+            <a:r>
+              <a:rPr lang="en-US" sz="1200" dirty="0" err="1">
+                <a:solidFill>
+                  <a:schemeClr val="tx1"/>
+                </a:solidFill>
+              </a:rPr>
+              <a:t>serviceds</a:t>
+            </a:r>
+            <a:endParaRPr lang="en-US" sz="1200" dirty="0">
+              <a:solidFill>
+                <a:schemeClr val="tx1"/>
+              </a:solidFill>
+            </a:endParaRPr>
+          </a:p>
+        </p:txBody>
+      </p:sp>
+      <p:sp>
+        <p:nvSpPr>
+          <p:cNvPr id="12" name="Rectangle 11">
+            <a:extLst>
+              <a:ext uri="{FF2B5EF4-FFF2-40B4-BE49-F238E27FC236}">
+                <a16:creationId xmlns:a16="http://schemas.microsoft.com/office/drawing/2014/main" id="{7A3EDBB5-60E0-7F9C-200F-016EDA68FFE2}"/>
+              </a:ext>
+            </a:extLst>
+          </p:cNvPr>
+          <p:cNvSpPr/>
+          <p:nvPr/>
+        </p:nvSpPr>
+        <p:spPr>
+          <a:xfrm>
+            <a:off x="4580962" y="4551652"/>
+            <a:ext cx="2766193" cy="1701861"/>
+          </a:xfrm>
+          <a:prstGeom prst="rect">
+            <a:avLst/>
+          </a:prstGeom>
+          <a:solidFill>
+            <a:schemeClr val="accent6">
+              <a:lumMod val="20000"/>
+              <a:lumOff val="80000"/>
+            </a:schemeClr>
+          </a:solidFill>
+        </p:spPr>
+        <p:style>
+          <a:lnRef idx="2">
+            <a:schemeClr val="accent1">
+              <a:shade val="15000"/>
+            </a:schemeClr>
+          </a:lnRef>
+          <a:fillRef idx="1">
+            <a:schemeClr val="accent1"/>
+          </a:fillRef>
+          <a:effectRef idx="0">
+            <a:schemeClr val="accent1"/>
+          </a:effectRef>
+          <a:fontRef idx="minor">
+            <a:schemeClr val="lt1"/>
+          </a:fontRef>
+        </p:style>
+        <p:txBody>
+          <a:bodyPr rtlCol="0" anchor="t"/>
+          <a:lstStyle/>
+          <a:p>
+            <a:pPr marL="285750" indent="-285750">
+              <a:buFont typeface="Arial" panose="020B0604020202020204" pitchFamily="34" charset="0"/>
+              <a:buChar char="•"/>
+            </a:pPr>
+            <a:r>
+              <a:rPr lang="en-US" sz="1200" dirty="0">
+                <a:solidFill>
+                  <a:schemeClr val="tx1"/>
+                </a:solidFill>
+              </a:rPr>
+              <a:t>DB services, Data Bae</a:t>
+            </a:r>
+          </a:p>
+          <a:p>
+            <a:pPr marL="285750" indent="-285750">
+              <a:buFont typeface="Arial" panose="020B0604020202020204" pitchFamily="34" charset="0"/>
+              <a:buChar char="•"/>
+            </a:pPr>
+            <a:r>
+              <a:rPr lang="en-US" sz="1200" dirty="0">
+                <a:solidFill>
+                  <a:schemeClr val="tx1"/>
+                </a:solidFill>
+              </a:rPr>
+              <a:t>AI GPU services</a:t>
+            </a:r>
+          </a:p>
+          <a:p>
+            <a:pPr marL="285750" indent="-285750">
+              <a:buFont typeface="Arial" panose="020B0604020202020204" pitchFamily="34" charset="0"/>
+              <a:buChar char="•"/>
+            </a:pPr>
+            <a:r>
+              <a:rPr lang="en-US" sz="1200" dirty="0">
+                <a:solidFill>
+                  <a:schemeClr val="tx1"/>
+                </a:solidFill>
+              </a:rPr>
+              <a:t>Account: </a:t>
+            </a:r>
+            <a:r>
+              <a:rPr lang="en-US" sz="1200" dirty="0">
+                <a:solidFill>
+                  <a:schemeClr val="tx1"/>
+                </a:solidFill>
+                <a:hlinkClick r:id="rId2"/>
+              </a:rPr>
+              <a:t>skip.snow@gmail.com</a:t>
+            </a:r>
+            <a:endParaRPr lang="en-US" sz="1200" dirty="0">
+              <a:solidFill>
+                <a:schemeClr val="tx1"/>
+              </a:solidFill>
+            </a:endParaRPr>
+          </a:p>
+          <a:p>
+            <a:pPr marL="285750" indent="-285750">
+              <a:buFont typeface="Arial" panose="020B0604020202020204" pitchFamily="34" charset="0"/>
+              <a:buChar char="•"/>
+            </a:pPr>
+            <a:r>
+              <a:rPr lang="en-US" sz="1200" dirty="0">
+                <a:solidFill>
+                  <a:schemeClr val="tx1"/>
+                </a:solidFill>
+              </a:rPr>
+              <a:t>Cluster: ChatHealthyDB_dev</a:t>
+            </a:r>
+          </a:p>
+          <a:p>
+            <a:pPr marL="742950" lvl="1" indent="-285750">
+              <a:buFont typeface="Arial" panose="020B0604020202020204" pitchFamily="34" charset="0"/>
+              <a:buChar char="•"/>
+            </a:pPr>
+            <a:endParaRPr lang="en-US" sz="1200" dirty="0">
+              <a:solidFill>
+                <a:schemeClr val="tx1"/>
+              </a:solidFill>
+            </a:endParaRPr>
+          </a:p>
+          <a:p>
+            <a:pPr marL="285750" indent="-285750">
+              <a:buFont typeface="Arial" panose="020B0604020202020204" pitchFamily="34" charset="0"/>
+              <a:buChar char="•"/>
+            </a:pPr>
+            <a:endParaRPr lang="en-US" sz="1200" dirty="0">
+              <a:solidFill>
+                <a:schemeClr val="tx1"/>
+              </a:solidFill>
+            </a:endParaRPr>
+          </a:p>
+        </p:txBody>
+      </p:sp>
+      <p:sp>
+        <p:nvSpPr>
+          <p:cNvPr id="13" name="Rectangle 12">
+            <a:extLst>
+              <a:ext uri="{FF2B5EF4-FFF2-40B4-BE49-F238E27FC236}">
+                <a16:creationId xmlns:a16="http://schemas.microsoft.com/office/drawing/2014/main" id="{3532AE32-B87B-CF0F-A5DA-314BABF7888C}"/>
+              </a:ext>
+            </a:extLst>
+          </p:cNvPr>
+          <p:cNvSpPr/>
+          <p:nvPr/>
+        </p:nvSpPr>
+        <p:spPr>
+          <a:xfrm>
+            <a:off x="8012357" y="3731243"/>
+            <a:ext cx="3635503" cy="2258785"/>
+          </a:xfrm>
+          <a:prstGeom prst="rect">
+            <a:avLst/>
+          </a:prstGeom>
+          <a:solidFill>
+            <a:schemeClr val="accent6">
+              <a:lumMod val="20000"/>
+              <a:lumOff val="80000"/>
+            </a:schemeClr>
+          </a:solidFill>
+        </p:spPr>
+        <p:style>
+          <a:lnRef idx="2">
+            <a:schemeClr val="accent1">
+              <a:shade val="15000"/>
+            </a:schemeClr>
+          </a:lnRef>
+          <a:fillRef idx="1">
+            <a:schemeClr val="accent1"/>
+          </a:fillRef>
+          <a:effectRef idx="0">
+            <a:schemeClr val="accent1"/>
+          </a:effectRef>
+          <a:fontRef idx="minor">
+            <a:schemeClr val="lt1"/>
+          </a:fontRef>
+        </p:style>
+        <p:txBody>
+          <a:bodyPr rtlCol="0" anchor="t"/>
+          <a:lstStyle/>
+          <a:p>
+            <a:pPr marL="285750" indent="-285750">
+              <a:buFont typeface="Arial" panose="020B0604020202020204" pitchFamily="34" charset="0"/>
+              <a:buChar char="•"/>
+            </a:pPr>
+            <a:r>
+              <a:rPr lang="en-US" sz="1200" dirty="0">
+                <a:solidFill>
+                  <a:schemeClr val="tx1"/>
+                </a:solidFill>
+              </a:rPr>
+              <a:t>Git Hub</a:t>
+            </a:r>
+          </a:p>
+          <a:p>
+            <a:pPr marL="285750" indent="-285750">
+              <a:buFont typeface="Arial" panose="020B0604020202020204" pitchFamily="34" charset="0"/>
+              <a:buChar char="•"/>
+            </a:pPr>
+            <a:r>
+              <a:rPr lang="en-US" sz="1200" dirty="0">
+                <a:solidFill>
+                  <a:schemeClr val="tx1"/>
+                </a:solidFill>
+              </a:rPr>
+              <a:t>Account: </a:t>
+            </a:r>
+            <a:r>
+              <a:rPr lang="en-US" sz="1200" dirty="0">
+                <a:solidFill>
+                  <a:schemeClr val="tx1"/>
+                </a:solidFill>
+                <a:hlinkClick r:id="rId2"/>
+              </a:rPr>
+              <a:t>skip.snow@gmail.com</a:t>
+            </a:r>
+            <a:endParaRPr lang="en-US" sz="1200" dirty="0">
+              <a:solidFill>
+                <a:schemeClr val="tx1"/>
+              </a:solidFill>
+            </a:endParaRPr>
+          </a:p>
+          <a:p>
+            <a:pPr marL="285750" indent="-285750">
+              <a:buFont typeface="Arial" panose="020B0604020202020204" pitchFamily="34" charset="0"/>
+              <a:buChar char="•"/>
+            </a:pPr>
+            <a:r>
+              <a:rPr lang="en-US" sz="1200" dirty="0">
+                <a:solidFill>
+                  <a:schemeClr val="tx1"/>
+                </a:solidFill>
+              </a:rPr>
+              <a:t>Repos:</a:t>
+            </a:r>
+          </a:p>
+          <a:p>
+            <a:pPr marL="742950" lvl="1" indent="-285750">
+              <a:buFont typeface="Arial" panose="020B0604020202020204" pitchFamily="34" charset="0"/>
+              <a:buChar char="•"/>
+            </a:pPr>
+            <a:r>
+              <a:rPr lang="en-US" sz="1200" dirty="0">
+                <a:solidFill>
+                  <a:schemeClr val="tx1"/>
+                </a:solidFill>
+              </a:rPr>
+              <a:t>SkipSnow/</a:t>
+            </a:r>
+            <a:r>
+              <a:rPr lang="en-US" sz="1200" dirty="0" err="1">
+                <a:solidFill>
+                  <a:schemeClr val="tx1"/>
+                </a:solidFill>
+              </a:rPr>
+              <a:t>findCare</a:t>
+            </a:r>
+            <a:endParaRPr lang="en-US" sz="1200" dirty="0">
+              <a:solidFill>
+                <a:schemeClr val="tx1"/>
+              </a:solidFill>
+            </a:endParaRPr>
+          </a:p>
+          <a:p>
+            <a:pPr marL="742950" lvl="1" indent="-285750">
+              <a:buFont typeface="Arial" panose="020B0604020202020204" pitchFamily="34" charset="0"/>
+              <a:buChar char="•"/>
+            </a:pPr>
+            <a:r>
+              <a:rPr lang="en-US" sz="1200" dirty="0">
+                <a:solidFill>
+                  <a:schemeClr val="tx1"/>
+                </a:solidFill>
+              </a:rPr>
+              <a:t>SkipSnow/</a:t>
+            </a:r>
+            <a:r>
+              <a:rPr lang="en-US" sz="1200" dirty="0" err="1">
+                <a:solidFill>
+                  <a:schemeClr val="tx1"/>
+                </a:solidFill>
+              </a:rPr>
+              <a:t>ChatHealthyDataPipeline</a:t>
+            </a:r>
+            <a:endParaRPr lang="en-US" sz="1200" dirty="0">
+              <a:solidFill>
+                <a:schemeClr val="tx1"/>
+              </a:solidFill>
+            </a:endParaRPr>
+          </a:p>
+          <a:p>
+            <a:pPr marL="285750" indent="-285750">
+              <a:buFont typeface="Arial" panose="020B0604020202020204" pitchFamily="34" charset="0"/>
+              <a:buChar char="•"/>
+            </a:pPr>
+            <a:r>
+              <a:rPr lang="en-US" sz="1200" dirty="0">
+                <a:solidFill>
+                  <a:schemeClr val="tx1"/>
+                </a:solidFill>
+              </a:rPr>
+              <a:t>Dev</a:t>
+            </a:r>
+          </a:p>
+          <a:p>
+            <a:pPr marL="742950" lvl="1" indent="-285750">
+              <a:buFont typeface="Arial" panose="020B0604020202020204" pitchFamily="34" charset="0"/>
+              <a:buChar char="•"/>
+            </a:pPr>
+            <a:r>
+              <a:rPr lang="en-US" sz="1200" dirty="0">
+                <a:solidFill>
+                  <a:schemeClr val="tx1"/>
+                </a:solidFill>
+              </a:rPr>
+              <a:t>Cursor: deploy from cursor </a:t>
+            </a:r>
+          </a:p>
+          <a:p>
+            <a:pPr marL="1200150" lvl="2" indent="-285750">
+              <a:buFont typeface="Arial" panose="020B0604020202020204" pitchFamily="34" charset="0"/>
+              <a:buChar char="•"/>
+            </a:pPr>
+            <a:r>
+              <a:rPr lang="en-US" sz="1200" dirty="0">
+                <a:solidFill>
+                  <a:schemeClr val="tx1"/>
+                </a:solidFill>
+              </a:rPr>
+              <a:t>Model cursor’s native</a:t>
+            </a:r>
+          </a:p>
+          <a:p>
+            <a:pPr marL="742950" lvl="1" indent="-285750">
+              <a:buFont typeface="Arial" panose="020B0604020202020204" pitchFamily="34" charset="0"/>
+              <a:buChar char="•"/>
+            </a:pPr>
+            <a:r>
+              <a:rPr lang="en-US" sz="1200" dirty="0">
+                <a:solidFill>
+                  <a:schemeClr val="tx1"/>
+                </a:solidFill>
+              </a:rPr>
+              <a:t>Cluster: ChatHealthyDB_dev</a:t>
+            </a:r>
+          </a:p>
+          <a:p>
+            <a:pPr marL="742950" lvl="1" indent="-285750">
+              <a:buFont typeface="Arial" panose="020B0604020202020204" pitchFamily="34" charset="0"/>
+              <a:buChar char="•"/>
+            </a:pPr>
+            <a:r>
+              <a:rPr lang="en-US" sz="1200" dirty="0">
+                <a:solidFill>
+                  <a:schemeClr val="tx1"/>
+                </a:solidFill>
+              </a:rPr>
+              <a:t>Claud Projects via claude.ai</a:t>
+            </a:r>
+          </a:p>
+          <a:p>
+            <a:pPr marL="1200150" lvl="2" indent="-285750">
+              <a:buFont typeface="Arial" panose="020B0604020202020204" pitchFamily="34" charset="0"/>
+              <a:buChar char="•"/>
+            </a:pPr>
+            <a:r>
+              <a:rPr lang="en-US" sz="1200" dirty="0">
+                <a:solidFill>
+                  <a:schemeClr val="tx1"/>
+                </a:solidFill>
+              </a:rPr>
+              <a:t>MD file for project prompt</a:t>
+            </a:r>
+          </a:p>
+          <a:p>
+            <a:pPr marL="742950" lvl="1" indent="-285750">
+              <a:buFont typeface="Arial" panose="020B0604020202020204" pitchFamily="34" charset="0"/>
+              <a:buChar char="•"/>
+            </a:pPr>
+            <a:endParaRPr lang="en-US" sz="1200" dirty="0">
+              <a:solidFill>
+                <a:schemeClr val="tx1"/>
+              </a:solidFill>
+            </a:endParaRPr>
+          </a:p>
+          <a:p>
+            <a:pPr marL="742950" lvl="1" indent="-285750">
+              <a:buFont typeface="Arial" panose="020B0604020202020204" pitchFamily="34" charset="0"/>
+              <a:buChar char="•"/>
+            </a:pPr>
+            <a:endParaRPr lang="en-US" sz="1200" dirty="0">
+              <a:solidFill>
+                <a:schemeClr val="tx1"/>
+              </a:solidFill>
+            </a:endParaRPr>
+          </a:p>
+          <a:p>
+            <a:pPr marL="285750" indent="-285750">
+              <a:buFont typeface="Arial" panose="020B0604020202020204" pitchFamily="34" charset="0"/>
+              <a:buChar char="•"/>
+            </a:pPr>
+            <a:endParaRPr lang="en-US" sz="1200" dirty="0">
+              <a:solidFill>
+                <a:schemeClr val="tx1"/>
+              </a:solidFill>
+            </a:endParaRPr>
           </a:p>
         </p:txBody>
       </p:sp>
@@ -3854,92 +5195,6 @@
     <p:extLst>
       <p:ext uri="{BB962C8B-B14F-4D97-AF65-F5344CB8AC3E}">
         <p14:creationId xmlns:p14="http://schemas.microsoft.com/office/powerpoint/2010/main" val="649129236"/>
-      </p:ext>
-    </p:extLst>
-  </p:cSld>
-  <p:clrMapOvr>
-    <a:masterClrMapping/>
-  </p:clrMapOvr>
-</p:sld>
-</file>
-
-<file path=ppt/slides/slide4.xml><?xml version="1.0" encoding="utf-8"?>
-<p:sld xmlns:a="http://schemas.openxmlformats.org/drawingml/2006/main" xmlns:r="http://schemas.openxmlformats.org/officeDocument/2006/relationships" xmlns:p="http://schemas.openxmlformats.org/presentationml/2006/main">
-  <p:cSld>
-    <p:spTree>
-      <p:nvGrpSpPr>
-        <p:cNvPr id="1" name=""/>
-        <p:cNvGrpSpPr/>
-        <p:nvPr/>
-      </p:nvGrpSpPr>
-      <p:grpSpPr>
-        <a:xfrm>
-          <a:off x="0" y="0"/>
-          <a:ext cx="0" cy="0"/>
-          <a:chOff x="0" y="0"/>
-          <a:chExt cx="0" cy="0"/>
-        </a:xfrm>
-      </p:grpSpPr>
-      <p:sp>
-        <p:nvSpPr>
-          <p:cNvPr id="2" name="Title 1">
-            <a:extLst>
-              <a:ext uri="{FF2B5EF4-FFF2-40B4-BE49-F238E27FC236}">
-                <a16:creationId xmlns:a16="http://schemas.microsoft.com/office/drawing/2014/main" id="{5007F60F-8368-905B-9F42-75E39B38819B}"/>
-              </a:ext>
-            </a:extLst>
-          </p:cNvPr>
-          <p:cNvSpPr>
-            <a:spLocks noGrp="1"/>
-          </p:cNvSpPr>
-          <p:nvPr>
-            <p:ph type="title"/>
-          </p:nvPr>
-        </p:nvSpPr>
-        <p:spPr/>
-        <p:txBody>
-          <a:bodyPr/>
-          <a:lstStyle/>
-          <a:p>
-            <a:r>
-              <a:rPr lang="en-US" dirty="0"/>
-              <a:t>Commercial application of web site</a:t>
-            </a:r>
-          </a:p>
-        </p:txBody>
-      </p:sp>
-      <p:sp>
-        <p:nvSpPr>
-          <p:cNvPr id="3" name="Content Placeholder 2">
-            <a:extLst>
-              <a:ext uri="{FF2B5EF4-FFF2-40B4-BE49-F238E27FC236}">
-                <a16:creationId xmlns:a16="http://schemas.microsoft.com/office/drawing/2014/main" id="{DF32CF06-6CF1-3D56-A57E-AD0B5EAE779B}"/>
-              </a:ext>
-            </a:extLst>
-          </p:cNvPr>
-          <p:cNvSpPr>
-            <a:spLocks noGrp="1"/>
-          </p:cNvSpPr>
-          <p:nvPr>
-            <p:ph idx="1"/>
-          </p:nvPr>
-        </p:nvSpPr>
-        <p:spPr/>
-        <p:txBody>
-          <a:bodyPr/>
-          <a:lstStyle/>
-          <a:p>
-            <a:r>
-              <a:rPr lang="en-US" dirty="0"/>
-              <a:t>As of now this is thought of as an AI portfolio piece by Skip Snow without commercial implications.</a:t>
-            </a:r>
-          </a:p>
-        </p:txBody>
-      </p:sp>
-    </p:spTree>
-    <p:extLst>
-      <p:ext uri="{BB962C8B-B14F-4D97-AF65-F5344CB8AC3E}">
-        <p14:creationId xmlns:p14="http://schemas.microsoft.com/office/powerpoint/2010/main" val="2505143561"/>
       </p:ext>
     </p:extLst>
   </p:cSld>
@@ -3971,7 +5226,7 @@
           <p:cNvPr id="2" name="Title 1">
             <a:extLst>
               <a:ext uri="{FF2B5EF4-FFF2-40B4-BE49-F238E27FC236}">
-                <a16:creationId xmlns:a16="http://schemas.microsoft.com/office/drawing/2014/main" id="{191ADB60-E9B2-1519-D538-28CD02C88F06}"/>
+                <a16:creationId xmlns:a16="http://schemas.microsoft.com/office/drawing/2014/main" id="{58E0F0C2-5628-20FC-FBFA-752AAE857788}"/>
               </a:ext>
             </a:extLst>
           </p:cNvPr>
@@ -3982,59 +5237,133 @@
             <p:ph type="title"/>
           </p:nvPr>
         </p:nvSpPr>
-        <p:spPr/>
+        <p:spPr>
+          <a:xfrm>
+            <a:off x="0" y="40006"/>
+            <a:ext cx="10515600" cy="908262"/>
+          </a:xfrm>
+        </p:spPr>
         <p:txBody>
           <a:bodyPr/>
           <a:lstStyle/>
           <a:p>
             <a:r>
               <a:rPr lang="en-US" dirty="0"/>
-              <a:t>Data Pipelines</a:t>
-            </a:r>
-          </a:p>
-        </p:txBody>
-      </p:sp>
-      <p:sp>
-        <p:nvSpPr>
-          <p:cNvPr id="3" name="Content Placeholder 2">
-            <a:extLst>
-              <a:ext uri="{FF2B5EF4-FFF2-40B4-BE49-F238E27FC236}">
-                <a16:creationId xmlns:a16="http://schemas.microsoft.com/office/drawing/2014/main" id="{B36CE97F-0AEB-E9C9-CD62-E88A8E13296E}"/>
-              </a:ext>
-            </a:extLst>
-          </p:cNvPr>
-          <p:cNvSpPr>
-            <a:spLocks noGrp="1"/>
-          </p:cNvSpPr>
-          <p:nvPr>
-            <p:ph idx="1"/>
-          </p:nvPr>
-        </p:nvSpPr>
-        <p:spPr/>
-        <p:txBody>
-          <a:bodyPr/>
-          <a:lstStyle/>
-          <a:p>
+              <a:t>Web site architecture</a:t>
+            </a:r>
+          </a:p>
+        </p:txBody>
+      </p:sp>
+      <p:pic>
+        <p:nvPicPr>
+          <p:cNvPr id="4" name="Picture 3">
+            <a:extLst>
+              <a:ext uri="{FF2B5EF4-FFF2-40B4-BE49-F238E27FC236}">
+                <a16:creationId xmlns:a16="http://schemas.microsoft.com/office/drawing/2014/main" id="{3E4950F8-69A0-4116-2761-7F9E72010F98}"/>
+              </a:ext>
+            </a:extLst>
+          </p:cNvPr>
+          <p:cNvPicPr>
+            <a:picLocks noChangeAspect="1"/>
+          </p:cNvPicPr>
+          <p:nvPr/>
+        </p:nvPicPr>
+        <p:blipFill>
+          <a:blip r:embed="rId2"/>
+          <a:stretch>
+            <a:fillRect/>
+          </a:stretch>
+        </p:blipFill>
+        <p:spPr>
+          <a:xfrm>
+            <a:off x="4748989" y="740011"/>
+            <a:ext cx="7218608" cy="5879206"/>
+          </a:xfrm>
+          <a:prstGeom prst="rect">
+            <a:avLst/>
+          </a:prstGeom>
+          <a:ln>
+            <a:solidFill>
+              <a:schemeClr val="accent1"/>
+            </a:solidFill>
+          </a:ln>
+        </p:spPr>
+      </p:pic>
+      <p:sp>
+        <p:nvSpPr>
+          <p:cNvPr id="5" name="TextBox 4">
+            <a:extLst>
+              <a:ext uri="{FF2B5EF4-FFF2-40B4-BE49-F238E27FC236}">
+                <a16:creationId xmlns:a16="http://schemas.microsoft.com/office/drawing/2014/main" id="{9CACBB8C-0763-C364-78C0-8D7E11D81AA1}"/>
+              </a:ext>
+            </a:extLst>
+          </p:cNvPr>
+          <p:cNvSpPr txBox="1"/>
+          <p:nvPr/>
+        </p:nvSpPr>
+        <p:spPr>
+          <a:xfrm>
+            <a:off x="216747" y="1259840"/>
+            <a:ext cx="4301066" cy="3693319"/>
+          </a:xfrm>
+          <a:prstGeom prst="rect">
+            <a:avLst/>
+          </a:prstGeom>
+          <a:noFill/>
+          <a:ln>
+            <a:solidFill>
+              <a:schemeClr val="accent1"/>
+            </a:solidFill>
+          </a:ln>
+        </p:spPr>
+        <p:txBody>
+          <a:bodyPr wrap="square" rtlCol="0">
+            <a:spAutoFit/>
+          </a:bodyPr>
+          <a:lstStyle/>
+          <a:p>
+            <a:pPr marL="285750" indent="-285750">
+              <a:buFont typeface="Arial" panose="020B0604020202020204" pitchFamily="34" charset="0"/>
+              <a:buChar char="•"/>
+            </a:pPr>
             <a:r>
               <a:rPr lang="en-US" dirty="0"/>
-              <a:t>There are several data sources that contribute to this effort and they must be kept fresh. This means that on a schedule the data must be refreshed by the pipeline without human oversight.</a:t>
-            </a:r>
-          </a:p>
-          <a:p>
+              <a:t>The AI logic is done via a Gradio services hosted on spaces. on Hugging Face. </a:t>
+            </a:r>
+          </a:p>
+          <a:p>
+            <a:pPr marL="285750" indent="-285750">
+              <a:buFont typeface="Arial" panose="020B0604020202020204" pitchFamily="34" charset="0"/>
+              <a:buChar char="•"/>
+            </a:pPr>
             <a:r>
               <a:rPr lang="en-US" dirty="0"/>
-              <a:t>Major data sources</a:t>
-            </a:r>
-          </a:p>
-          <a:p>
-            <a:pPr lvl="1"/>
+              <a:t>This component is  embedded via an </a:t>
+            </a:r>
+            <a:r>
+              <a:rPr lang="en-US" dirty="0" err="1"/>
+              <a:t>Iframe</a:t>
+            </a:r>
             <a:r>
               <a:rPr lang="en-US" dirty="0"/>
-              <a:t>National provider data</a:t>
-            </a:r>
-          </a:p>
-          <a:p>
-            <a:pPr lvl="2"/>
+              <a:t> into  the home page of the site.</a:t>
+            </a:r>
+          </a:p>
+          <a:p>
+            <a:pPr marL="285750" indent="-285750">
+              <a:buFont typeface="Arial" panose="020B0604020202020204" pitchFamily="34" charset="0"/>
+              <a:buChar char="•"/>
+            </a:pPr>
+            <a:r>
+              <a:rPr lang="en-US" dirty="0"/>
+              <a:t>At this point one AI interface is anticipated to handle all use cases. The ‘about us will be a static page that leads to many sub pages about the chatHealthy.ai business.  Which currently is SkipSnow doing business as chatHealthy.ai.</a:t>
+            </a:r>
+          </a:p>
+          <a:p>
+            <a:pPr marL="285750" indent="-285750">
+              <a:buFont typeface="Arial" panose="020B0604020202020204" pitchFamily="34" charset="0"/>
+              <a:buChar char="•"/>
+            </a:pPr>
             <a:endParaRPr lang="en-US" dirty="0"/>
           </a:p>
         </p:txBody>
@@ -4042,7 +5371,7 @@
     </p:spTree>
     <p:extLst>
       <p:ext uri="{BB962C8B-B14F-4D97-AF65-F5344CB8AC3E}">
-        <p14:creationId xmlns:p14="http://schemas.microsoft.com/office/powerpoint/2010/main" val="2213259797"/>
+        <p14:creationId xmlns:p14="http://schemas.microsoft.com/office/powerpoint/2010/main" val="73186097"/>
       </p:ext>
     </p:extLst>
   </p:cSld>
@@ -4069,63 +5398,40 @@
           <a:chExt cx="0" cy="0"/>
         </a:xfrm>
       </p:grpSpPr>
-      <p:sp>
-        <p:nvSpPr>
-          <p:cNvPr id="4" name="Title 3">
-            <a:extLst>
-              <a:ext uri="{FF2B5EF4-FFF2-40B4-BE49-F238E27FC236}">
-                <a16:creationId xmlns:a16="http://schemas.microsoft.com/office/drawing/2014/main" id="{2B7E0430-9266-C61F-62F1-66ACEFBC489D}"/>
-              </a:ext>
-            </a:extLst>
-          </p:cNvPr>
-          <p:cNvSpPr>
-            <a:spLocks noGrp="1"/>
-          </p:cNvSpPr>
-          <p:nvPr>
-            <p:ph type="title"/>
-          </p:nvPr>
-        </p:nvSpPr>
-        <p:spPr/>
-        <p:txBody>
-          <a:bodyPr/>
-          <a:lstStyle/>
-          <a:p>
-            <a:r>
-              <a:rPr lang="en-US" dirty="0"/>
-              <a:t>Appendix</a:t>
-            </a:r>
-          </a:p>
-        </p:txBody>
-      </p:sp>
-      <p:sp>
-        <p:nvSpPr>
-          <p:cNvPr id="5" name="Content Placeholder 4">
-            <a:extLst>
-              <a:ext uri="{FF2B5EF4-FFF2-40B4-BE49-F238E27FC236}">
-                <a16:creationId xmlns:a16="http://schemas.microsoft.com/office/drawing/2014/main" id="{4ED5FF93-4C27-E8C8-FFF0-5BFD07E49236}"/>
-              </a:ext>
-            </a:extLst>
-          </p:cNvPr>
-          <p:cNvSpPr>
-            <a:spLocks noGrp="1"/>
-          </p:cNvSpPr>
-          <p:nvPr>
-            <p:ph idx="1"/>
-          </p:nvPr>
-        </p:nvSpPr>
-        <p:spPr/>
-        <p:txBody>
-          <a:bodyPr/>
-          <a:lstStyle/>
-          <a:p>
-            <a:endParaRPr lang="en-US"/>
-          </a:p>
-        </p:txBody>
-      </p:sp>
+      <p:pic>
+        <p:nvPicPr>
+          <p:cNvPr id="7" name="Picture 6">
+            <a:extLst>
+              <a:ext uri="{FF2B5EF4-FFF2-40B4-BE49-F238E27FC236}">
+                <a16:creationId xmlns:a16="http://schemas.microsoft.com/office/drawing/2014/main" id="{A2E0819F-25E0-3DEE-FACE-DDEC598120C3}"/>
+              </a:ext>
+            </a:extLst>
+          </p:cNvPr>
+          <p:cNvPicPr>
+            <a:picLocks noChangeAspect="1"/>
+          </p:cNvPicPr>
+          <p:nvPr/>
+        </p:nvPicPr>
+        <p:blipFill>
+          <a:blip r:embed="rId2"/>
+          <a:stretch>
+            <a:fillRect/>
+          </a:stretch>
+        </p:blipFill>
+        <p:spPr>
+          <a:xfrm>
+            <a:off x="626209" y="374352"/>
+            <a:ext cx="8485942" cy="5099774"/>
+          </a:xfrm>
+          <a:prstGeom prst="rect">
+            <a:avLst/>
+          </a:prstGeom>
+        </p:spPr>
+      </p:pic>
     </p:spTree>
     <p:extLst>
       <p:ext uri="{BB962C8B-B14F-4D97-AF65-F5344CB8AC3E}">
-        <p14:creationId xmlns:p14="http://schemas.microsoft.com/office/powerpoint/2010/main" val="997819748"/>
+        <p14:creationId xmlns:p14="http://schemas.microsoft.com/office/powerpoint/2010/main" val="2417474138"/>
       </p:ext>
     </p:extLst>
   </p:cSld>
@@ -4157,7 +5463,7 @@
           <p:cNvPr id="2" name="Title 1">
             <a:extLst>
               <a:ext uri="{FF2B5EF4-FFF2-40B4-BE49-F238E27FC236}">
-                <a16:creationId xmlns:a16="http://schemas.microsoft.com/office/drawing/2014/main" id="{5AAD0D87-F2B0-8B2D-EF2E-46095805DFAF}"/>
+                <a16:creationId xmlns:a16="http://schemas.microsoft.com/office/drawing/2014/main" id="{5007F60F-8368-905B-9F42-75E39B38819B}"/>
               </a:ext>
             </a:extLst>
           </p:cNvPr>
@@ -4168,19 +5474,14 @@
             <p:ph type="title"/>
           </p:nvPr>
         </p:nvSpPr>
-        <p:spPr>
-          <a:xfrm>
-            <a:off x="838200" y="365126"/>
-            <a:ext cx="10515600" cy="840528"/>
-          </a:xfrm>
-        </p:spPr>
+        <p:spPr/>
         <p:txBody>
           <a:bodyPr/>
           <a:lstStyle/>
           <a:p>
             <a:r>
               <a:rPr lang="en-US" dirty="0"/>
-              <a:t>Azure deployment Architecture</a:t>
+              <a:t>Commercial application of web site</a:t>
             </a:r>
           </a:p>
         </p:txBody>
@@ -4190,7 +5491,7 @@
           <p:cNvPr id="3" name="Content Placeholder 2">
             <a:extLst>
               <a:ext uri="{FF2B5EF4-FFF2-40B4-BE49-F238E27FC236}">
-                <a16:creationId xmlns:a16="http://schemas.microsoft.com/office/drawing/2014/main" id="{B57A65A2-2228-D79B-C01D-3264AAB9155D}"/>
+                <a16:creationId xmlns:a16="http://schemas.microsoft.com/office/drawing/2014/main" id="{DF32CF06-6CF1-3D56-A57E-AD0B5EAE779B}"/>
               </a:ext>
             </a:extLst>
           </p:cNvPr>
@@ -4201,310 +5502,14 @@
             <p:ph idx="1"/>
           </p:nvPr>
         </p:nvSpPr>
-        <p:spPr>
-          <a:xfrm>
-            <a:off x="458894" y="1541145"/>
-            <a:ext cx="3787987" cy="4351338"/>
-          </a:xfrm>
-        </p:spPr>
-        <p:txBody>
-          <a:bodyPr>
-            <a:normAutofit fontScale="32500" lnSpcReduction="20000"/>
-          </a:bodyPr>
-          <a:lstStyle/>
-          <a:p>
-            <a:r>
-              <a:rPr lang="en-US"/>
-              <a:t>Subscription: ChatHealthy</a:t>
-            </a:r>
-          </a:p>
-          <a:p>
-            <a:r>
-              <a:rPr lang="en-US"/>
-              <a:t>└── Resource Group: ChatHealthyDataPipelines</a:t>
-            </a:r>
-          </a:p>
-          <a:p>
-            <a:r>
-              <a:rPr lang="en-US"/>
-              <a:t>    ├── Tag: environment → dev | qa | prod</a:t>
-            </a:r>
-          </a:p>
-          <a:p>
-            <a:r>
-              <a:rPr lang="en-US"/>
-              <a:t>    ├── Tag: version     → 1.0.0</a:t>
-            </a:r>
-          </a:p>
-          <a:p>
-            <a:r>
-              <a:rPr lang="en-US"/>
-              <a:t>    │</a:t>
-            </a:r>
-          </a:p>
-          <a:p>
-            <a:r>
-              <a:rPr lang="en-US"/>
-              <a:t>    ├── Namespace: PipelineInfrastructure [SHARED]</a:t>
-            </a:r>
-          </a:p>
-          <a:p>
-            <a:r>
-              <a:rPr lang="en-US"/>
-              <a:t>    │   ├── Storage Account [SHARED]</a:t>
-            </a:r>
-          </a:p>
-          <a:p>
-            <a:r>
-              <a:rPr lang="en-US"/>
-              <a:t>    │   │   └── Blob Container</a:t>
-            </a:r>
-          </a:p>
-          <a:p>
-            <a:r>
-              <a:rPr lang="en-US"/>
-              <a:t>    │   │       └── Tag: environment → dev</a:t>
-            </a:r>
-          </a:p>
-          <a:p>
-            <a:r>
-              <a:rPr lang="en-US"/>
-              <a:t>    │   ├── Virtual Network / Subnet [SHARED]</a:t>
-            </a:r>
-          </a:p>
-          <a:p>
-            <a:r>
-              <a:rPr lang="en-US"/>
-              <a:t>    │   └── Key Vault [SHARED]</a:t>
-            </a:r>
-          </a:p>
-          <a:p>
-            <a:r>
-              <a:rPr lang="en-US"/>
-              <a:t>    │</a:t>
-            </a:r>
-          </a:p>
-          <a:p>
-            <a:r>
-              <a:rPr lang="en-US"/>
-              <a:t>    └── Namespace: ProviderDataPipelineApp</a:t>
-            </a:r>
-          </a:p>
-          <a:p>
-            <a:r>
-              <a:rPr lang="en-US"/>
-              <a:t>        ├── Function App: FetchAndDistributeProviderData</a:t>
-            </a:r>
-          </a:p>
-          <a:p>
-            <a:r>
-              <a:rPr lang="en-US"/>
-              <a:t>        │   └── Tag: environment → dev</a:t>
-            </a:r>
-          </a:p>
-          <a:p>
-            <a:r>
-              <a:rPr lang="en-US"/>
-              <a:t>        ├── Function App: NPDBDataToMongo</a:t>
-            </a:r>
-          </a:p>
-          <a:p>
-            <a:r>
-              <a:rPr lang="en-US"/>
-              <a:t>        │   └── Tag: environment → dev</a:t>
-            </a:r>
-          </a:p>
-          <a:p>
-            <a:r>
-              <a:rPr lang="en-US"/>
-              <a:t>        └── Storage → ref: PipelineInfrastructure</a:t>
-            </a:r>
-            <a:endParaRPr lang="en-US" dirty="0"/>
-          </a:p>
-        </p:txBody>
-      </p:sp>
-      <p:sp>
-        <p:nvSpPr>
-          <p:cNvPr id="4" name="TextBox 3">
-            <a:extLst>
-              <a:ext uri="{FF2B5EF4-FFF2-40B4-BE49-F238E27FC236}">
-                <a16:creationId xmlns:a16="http://schemas.microsoft.com/office/drawing/2014/main" id="{D7F92A63-5EF3-52A3-0F23-0077A9ABC82E}"/>
-              </a:ext>
-            </a:extLst>
-          </p:cNvPr>
-          <p:cNvSpPr txBox="1"/>
-          <p:nvPr/>
-        </p:nvSpPr>
-        <p:spPr>
-          <a:xfrm>
-            <a:off x="3578012" y="1541145"/>
-            <a:ext cx="7775788" cy="4893647"/>
-          </a:xfrm>
-          <a:prstGeom prst="rect">
-            <a:avLst/>
-          </a:prstGeom>
-          <a:noFill/>
-        </p:spPr>
-        <p:txBody>
-          <a:bodyPr wrap="square" rtlCol="0">
-            <a:spAutoFit/>
-          </a:bodyPr>
-          <a:lstStyle/>
-          <a:p>
-            <a:pPr marL="285750" indent="-285750">
-              <a:buFont typeface="Arial" panose="020B0604020202020204" pitchFamily="34" charset="0"/>
-              <a:buChar char="•"/>
-            </a:pPr>
-            <a:r>
-              <a:rPr lang="en-US" sz="2400" dirty="0">
-                <a:solidFill>
-                  <a:schemeClr val="tx1">
-                    <a:lumMod val="65000"/>
-                    <a:lumOff val="35000"/>
-                  </a:schemeClr>
-                </a:solidFill>
-              </a:rPr>
-              <a:t>The use of deployment facts in a predictable matter allow for a business to respond to changes to its operating model. </a:t>
-            </a:r>
-          </a:p>
-          <a:p>
-            <a:pPr marL="742950" lvl="1" indent="-285750">
-              <a:buFont typeface="Arial" panose="020B0604020202020204" pitchFamily="34" charset="0"/>
-              <a:buChar char="•"/>
-            </a:pPr>
-            <a:r>
-              <a:rPr lang="en-US" sz="2400" dirty="0">
-                <a:solidFill>
-                  <a:schemeClr val="tx1">
-                    <a:lumMod val="65000"/>
-                    <a:lumOff val="35000"/>
-                  </a:schemeClr>
-                </a:solidFill>
-              </a:rPr>
-              <a:t>Resource groups can cross all boundaries but should be </a:t>
-            </a:r>
-            <a:r>
-              <a:rPr lang="en-US" sz="2400" dirty="0" err="1">
-                <a:solidFill>
-                  <a:schemeClr val="tx1">
-                    <a:lumMod val="65000"/>
-                    <a:lumOff val="35000"/>
-                  </a:schemeClr>
-                </a:solidFill>
-              </a:rPr>
-              <a:t>maped</a:t>
-            </a:r>
-            <a:r>
-              <a:rPr lang="en-US" sz="2400" dirty="0">
-                <a:solidFill>
-                  <a:schemeClr val="tx1">
-                    <a:lumMod val="65000"/>
-                    <a:lumOff val="35000"/>
-                  </a:schemeClr>
-                </a:solidFill>
-              </a:rPr>
-              <a:t> to an accounting and HR model. </a:t>
-            </a:r>
-          </a:p>
-          <a:p>
-            <a:pPr marL="742950" lvl="1" indent="-285750">
-              <a:buFont typeface="Arial" panose="020B0604020202020204" pitchFamily="34" charset="0"/>
-              <a:buChar char="•"/>
-            </a:pPr>
-            <a:r>
-              <a:rPr lang="en-US" sz="2400" dirty="0">
-                <a:solidFill>
-                  <a:schemeClr val="tx1">
-                    <a:lumMod val="65000"/>
-                    <a:lumOff val="35000"/>
-                  </a:schemeClr>
-                </a:solidFill>
-              </a:rPr>
-              <a:t>Other resource groups to be created are and two are planed, </a:t>
-            </a:r>
-          </a:p>
-          <a:p>
-            <a:pPr marL="1200150" lvl="2" indent="-285750">
-              <a:buFont typeface="Arial" panose="020B0604020202020204" pitchFamily="34" charset="0"/>
-              <a:buChar char="•"/>
-            </a:pPr>
-            <a:r>
-              <a:rPr lang="en-US" sz="2400" dirty="0">
-                <a:solidFill>
-                  <a:schemeClr val="tx1">
-                    <a:lumMod val="65000"/>
-                    <a:lumOff val="35000"/>
-                  </a:schemeClr>
-                </a:solidFill>
-              </a:rPr>
-              <a:t>Chat </a:t>
-            </a:r>
-            <a:r>
-              <a:rPr lang="en-US" sz="2400" dirty="0" err="1">
-                <a:solidFill>
-                  <a:schemeClr val="tx1">
-                    <a:lumMod val="65000"/>
-                    <a:lumOff val="35000"/>
-                  </a:schemeClr>
-                </a:solidFill>
-              </a:rPr>
-              <a:t>HealthyTest</a:t>
-            </a:r>
-            <a:r>
-              <a:rPr lang="en-US" sz="2400" dirty="0">
-                <a:solidFill>
-                  <a:schemeClr val="tx1">
-                    <a:lumMod val="65000"/>
-                    <a:lumOff val="35000"/>
-                  </a:schemeClr>
-                </a:solidFill>
-              </a:rPr>
-              <a:t>,  This is where the accuracy  chat Healthy's responses are tested against Boolean based criteria. And design decisions are revisited. </a:t>
-            </a:r>
-          </a:p>
-          <a:p>
-            <a:pPr marL="1200150" lvl="2" indent="-285750">
-              <a:buFont typeface="Arial" panose="020B0604020202020204" pitchFamily="34" charset="0"/>
-              <a:buChar char="•"/>
-            </a:pPr>
-            <a:r>
-              <a:rPr lang="en-US" sz="2400" dirty="0">
-                <a:solidFill>
-                  <a:schemeClr val="tx1">
-                    <a:lumMod val="65000"/>
-                    <a:lumOff val="35000"/>
-                  </a:schemeClr>
-                </a:solidFill>
-              </a:rPr>
-              <a:t>Find Care Run Time application</a:t>
-            </a:r>
-          </a:p>
-          <a:p>
-            <a:pPr marL="742950" lvl="1" indent="-285750">
-              <a:buFont typeface="Arial" panose="020B0604020202020204" pitchFamily="34" charset="0"/>
-              <a:buChar char="•"/>
-            </a:pPr>
-            <a:r>
-              <a:rPr lang="en-US" sz="2400" dirty="0">
-                <a:solidFill>
-                  <a:schemeClr val="tx1">
-                    <a:lumMod val="65000"/>
-                    <a:lumOff val="35000"/>
-                  </a:schemeClr>
-                </a:solidFill>
-              </a:rPr>
-              <a:t>There is only 1 azure subscription</a:t>
-            </a:r>
-            <a:r>
-              <a:rPr lang="en-US" dirty="0">
-                <a:solidFill>
-                  <a:schemeClr val="tx1">
-                    <a:lumMod val="65000"/>
-                    <a:lumOff val="35000"/>
-                  </a:schemeClr>
-                </a:solidFill>
-              </a:rPr>
-              <a:t>. </a:t>
+        <p:spPr/>
+        <p:txBody>
+          <a:bodyPr/>
+          <a:lstStyle/>
+          <a:p>
+            <a:r>
+              <a:rPr lang="en-US" dirty="0"/>
+              <a:t>As of now this is thought of as an AI portfolio piece by Skip Snow without commercial implications.</a:t>
             </a:r>
           </a:p>
         </p:txBody>
@@ -4512,7 +5517,193 @@
     </p:spTree>
     <p:extLst>
       <p:ext uri="{BB962C8B-B14F-4D97-AF65-F5344CB8AC3E}">
-        <p14:creationId xmlns:p14="http://schemas.microsoft.com/office/powerpoint/2010/main" val="1988505791"/>
+        <p14:creationId xmlns:p14="http://schemas.microsoft.com/office/powerpoint/2010/main" val="2505143561"/>
+      </p:ext>
+    </p:extLst>
+  </p:cSld>
+  <p:clrMapOvr>
+    <a:masterClrMapping/>
+  </p:clrMapOvr>
+</p:sld>
+</file>
+
+<file path=ppt/slides/slide8.xml><?xml version="1.0" encoding="utf-8"?>
+<p:sld xmlns:a="http://schemas.openxmlformats.org/drawingml/2006/main" xmlns:r="http://schemas.openxmlformats.org/officeDocument/2006/relationships" xmlns:p="http://schemas.openxmlformats.org/presentationml/2006/main">
+  <p:cSld>
+    <p:spTree>
+      <p:nvGrpSpPr>
+        <p:cNvPr id="1" name=""/>
+        <p:cNvGrpSpPr/>
+        <p:nvPr/>
+      </p:nvGrpSpPr>
+      <p:grpSpPr>
+        <a:xfrm>
+          <a:off x="0" y="0"/>
+          <a:ext cx="0" cy="0"/>
+          <a:chOff x="0" y="0"/>
+          <a:chExt cx="0" cy="0"/>
+        </a:xfrm>
+      </p:grpSpPr>
+      <p:sp>
+        <p:nvSpPr>
+          <p:cNvPr id="2" name="Title 1">
+            <a:extLst>
+              <a:ext uri="{FF2B5EF4-FFF2-40B4-BE49-F238E27FC236}">
+                <a16:creationId xmlns:a16="http://schemas.microsoft.com/office/drawing/2014/main" id="{191ADB60-E9B2-1519-D538-28CD02C88F06}"/>
+              </a:ext>
+            </a:extLst>
+          </p:cNvPr>
+          <p:cNvSpPr>
+            <a:spLocks noGrp="1"/>
+          </p:cNvSpPr>
+          <p:nvPr>
+            <p:ph type="title"/>
+          </p:nvPr>
+        </p:nvSpPr>
+        <p:spPr/>
+        <p:txBody>
+          <a:bodyPr/>
+          <a:lstStyle/>
+          <a:p>
+            <a:r>
+              <a:rPr lang="en-US" dirty="0"/>
+              <a:t>Data Pipelines</a:t>
+            </a:r>
+          </a:p>
+        </p:txBody>
+      </p:sp>
+      <p:sp>
+        <p:nvSpPr>
+          <p:cNvPr id="3" name="Content Placeholder 2">
+            <a:extLst>
+              <a:ext uri="{FF2B5EF4-FFF2-40B4-BE49-F238E27FC236}">
+                <a16:creationId xmlns:a16="http://schemas.microsoft.com/office/drawing/2014/main" id="{B36CE97F-0AEB-E9C9-CD62-E88A8E13296E}"/>
+              </a:ext>
+            </a:extLst>
+          </p:cNvPr>
+          <p:cNvSpPr>
+            <a:spLocks noGrp="1"/>
+          </p:cNvSpPr>
+          <p:nvPr>
+            <p:ph idx="1"/>
+          </p:nvPr>
+        </p:nvSpPr>
+        <p:spPr/>
+        <p:txBody>
+          <a:bodyPr/>
+          <a:lstStyle/>
+          <a:p>
+            <a:r>
+              <a:rPr lang="en-US" dirty="0"/>
+              <a:t>There are several data sources that contribute to this effort and they must be kept fresh. This means that on a schedule the data must be refreshed by the pipeline without human oversight.</a:t>
+            </a:r>
+          </a:p>
+          <a:p>
+            <a:r>
+              <a:rPr lang="en-US" dirty="0"/>
+              <a:t>Major data sources</a:t>
+            </a:r>
+          </a:p>
+          <a:p>
+            <a:pPr lvl="1"/>
+            <a:r>
+              <a:rPr lang="en-US" dirty="0"/>
+              <a:t>National provider data</a:t>
+            </a:r>
+          </a:p>
+          <a:p>
+            <a:pPr lvl="2"/>
+            <a:endParaRPr lang="en-US" dirty="0"/>
+          </a:p>
+        </p:txBody>
+      </p:sp>
+    </p:spTree>
+    <p:extLst>
+      <p:ext uri="{BB962C8B-B14F-4D97-AF65-F5344CB8AC3E}">
+        <p14:creationId xmlns:p14="http://schemas.microsoft.com/office/powerpoint/2010/main" val="2213259797"/>
+      </p:ext>
+    </p:extLst>
+  </p:cSld>
+  <p:clrMapOvr>
+    <a:masterClrMapping/>
+  </p:clrMapOvr>
+</p:sld>
+</file>
+
+<file path=ppt/slides/slide9.xml><?xml version="1.0" encoding="utf-8"?>
+<p:sld xmlns:a="http://schemas.openxmlformats.org/drawingml/2006/main" xmlns:r="http://schemas.openxmlformats.org/officeDocument/2006/relationships" xmlns:p="http://schemas.openxmlformats.org/presentationml/2006/main">
+  <p:cSld>
+    <p:spTree>
+      <p:nvGrpSpPr>
+        <p:cNvPr id="1" name=""/>
+        <p:cNvGrpSpPr/>
+        <p:nvPr/>
+      </p:nvGrpSpPr>
+      <p:grpSpPr>
+        <a:xfrm>
+          <a:off x="0" y="0"/>
+          <a:ext cx="0" cy="0"/>
+          <a:chOff x="0" y="0"/>
+          <a:chExt cx="0" cy="0"/>
+        </a:xfrm>
+      </p:grpSpPr>
+      <p:sp>
+        <p:nvSpPr>
+          <p:cNvPr id="4" name="Title 3">
+            <a:extLst>
+              <a:ext uri="{FF2B5EF4-FFF2-40B4-BE49-F238E27FC236}">
+                <a16:creationId xmlns:a16="http://schemas.microsoft.com/office/drawing/2014/main" id="{2B7E0430-9266-C61F-62F1-66ACEFBC489D}"/>
+              </a:ext>
+            </a:extLst>
+          </p:cNvPr>
+          <p:cNvSpPr>
+            <a:spLocks noGrp="1"/>
+          </p:cNvSpPr>
+          <p:nvPr>
+            <p:ph type="title"/>
+          </p:nvPr>
+        </p:nvSpPr>
+        <p:spPr/>
+        <p:txBody>
+          <a:bodyPr/>
+          <a:lstStyle/>
+          <a:p>
+            <a:r>
+              <a:rPr lang="en-US" dirty="0"/>
+              <a:t>Appendix</a:t>
+            </a:r>
+          </a:p>
+        </p:txBody>
+      </p:sp>
+      <p:sp>
+        <p:nvSpPr>
+          <p:cNvPr id="5" name="Content Placeholder 4">
+            <a:extLst>
+              <a:ext uri="{FF2B5EF4-FFF2-40B4-BE49-F238E27FC236}">
+                <a16:creationId xmlns:a16="http://schemas.microsoft.com/office/drawing/2014/main" id="{4ED5FF93-4C27-E8C8-FFF0-5BFD07E49236}"/>
+              </a:ext>
+            </a:extLst>
+          </p:cNvPr>
+          <p:cNvSpPr>
+            <a:spLocks noGrp="1"/>
+          </p:cNvSpPr>
+          <p:nvPr>
+            <p:ph idx="1"/>
+          </p:nvPr>
+        </p:nvSpPr>
+        <p:spPr/>
+        <p:txBody>
+          <a:bodyPr/>
+          <a:lstStyle/>
+          <a:p>
+            <a:endParaRPr lang="en-US"/>
+          </a:p>
+        </p:txBody>
+      </p:sp>
+    </p:spTree>
+    <p:extLst>
+      <p:ext uri="{BB962C8B-B14F-4D97-AF65-F5344CB8AC3E}">
+        <p14:creationId xmlns:p14="http://schemas.microsoft.com/office/powerpoint/2010/main" val="997819748"/>
       </p:ext>
     </p:extLst>
   </p:cSld>

</xml_diff>